<commit_message>
Reword slides for non-technical readers; add team names and IDs
Slides 1-11 replace jargon with plain descriptions (numbers unchanged).
Cover lists all five members with student IDs. Applies the queued 694/day
and R5 wording fixes.
</commit_message>
<xml_diff>
--- a/slides/Group03.pptx
+++ b/slides/Group03.pptx
@@ -118,31 +118,31 @@
   <p:extLst>
     <p:ext uri="{521415D9-36F7-43E2-AB2F-B90AF26B5E84}">
       <p14:sectionLst xmlns:p14="http://schemas.microsoft.com/office/powerpoint/2010/main">
-        <p14:section name="Introduction" id="{8669b80c-15da-8433-079b-bd5bd2e774a7}">
+        <p14:section name="Introduction" id="{40be89e4-fb38-bdb4-915a-131348b6baa1}">
           <p14:sldIdLst>
             <p14:sldId id="256"/>
           </p14:sldIdLst>
         </p14:section>
-        <p14:section name="System and workload" id="{36d4cb4f-5de0-b81d-491c-85e7b447aac5}">
+        <p14:section name="System and workload" id="{63c07d94-5f8d-2bdf-bdcd-ceb515c73309}">
           <p14:sldIdLst>
             <p14:sldId id="257"/>
             <p14:sldId id="258"/>
           </p14:sldIdLst>
         </p14:section>
-        <p14:section name="Requirements and candidates" id="{2f611fac-b390-d812-f1d7-4447d616887b}">
+        <p14:section name="Requirements and candidates" id="{0027618d-8779-e849-4297-c0dbdb973ad6}">
           <p14:sldIdLst>
             <p14:sldId id="259"/>
             <p14:sldId id="260"/>
           </p14:sldIdLst>
         </p14:section>
-        <p14:section name="Golden set and testing" id="{616e4131-2b9a-aed0-93a6-7cb7f4879a5c}">
+        <p14:section name="Golden set and testing" id="{85547ecd-d3a9-7cdf-d0a4-14bf98472614}">
           <p14:sldIdLst>
             <p14:sldId id="261"/>
             <p14:sldId id="262"/>
             <p14:sldId id="263"/>
           </p14:sldIdLst>
         </p14:section>
-        <p14:section name="Results and recommendation" id="{5089b4ab-96f1-0b4f-7fa4-c2385501bf2b}">
+        <p14:section name="Results and recommendation" id="{6a2fac3c-fa64-f15c-eef4-946fe0026c08}">
           <p14:sldIdLst>
             <p14:sldId id="264"/>
             <p14:sldId id="265"/>
@@ -185,7 +185,7 @@
                 </a:solidFill>
                 <a:latin typeface="+mn-lt"/>
               </a:rPr>
-              <a:t>Ticket length in characters (1,000 rows)</a:t>
+              <a:t>Ticket length in characters (our 1,000)</a:t>
             </a:r>
           </a:p>
         </c:rich>
@@ -252,25 +252,25 @@
                 <c:ptCount val="7"/>
                 <c:lvl>
                   <c:pt idx="0">
-                    <c:v>p5</c:v>
+                    <c:v>5%</c:v>
                   </c:pt>
                   <c:pt idx="1">
-                    <c:v>p25</c:v>
+                    <c:v>25%</c:v>
                   </c:pt>
                   <c:pt idx="2">
-                    <c:v>p50</c:v>
+                    <c:v>50%</c:v>
                   </c:pt>
                   <c:pt idx="3">
-                    <c:v>p75</c:v>
+                    <c:v>75%</c:v>
                   </c:pt>
                   <c:pt idx="4">
-                    <c:v>p95</c:v>
+                    <c:v>95%</c:v>
                   </c:pt>
                   <c:pt idx="5">
-                    <c:v>p99</c:v>
+                    <c:v>99%</c:v>
                   </c:pt>
                   <c:pt idx="6">
-                    <c:v>max</c:v>
+                    <c:v>Longest</c:v>
                   </c:pt>
                 </c:lvl>
               </c:multiLvlStrCache>
@@ -480,7 +480,7 @@
                 </a:solidFill>
                 <a:latin typeface="+mn-lt"/>
               </a:rPr>
-              <a:t>Per-category recall on the golden set (%), tickets per category in brackets</a:t>
+              <a:t>Share of each category sorted correctly (%); number of tickets in brackets</a:t>
             </a:r>
           </a:p>
         </c:rich>
@@ -857,7 +857,7 @@
               <c:strCache>
                 <c:ptCount val="1"/>
                 <c:pt idx="0">
-                  <c:v>R5 bar (70%)</c:v>
+                  <c:v>R5 target (70%)</c:v>
                 </c:pt>
               </c:strCache>
             </c:strRef>
@@ -1541,7 +1541,7 @@
           <a:p>
             <a:r>
               <a:rPr lang="en-US" dirty="0"/>
-              <a:t>Cover. Names/IDs to be completed by the team. Headline figures: results/accuracy/comparison.md (82.6%), results/load/qwen2.5-7b/1.73rpm_s3.5_run*.jtl (p95 6.06 s mean of 3 runs).</a:t>
+              <a:t>Cover. Headline figures: results/accuracy/comparison.md (82.6%), results/load/qwen2.5-7b/1.73rpm_s3.5_run*.jtl (p95 6.06 s mean of 3 runs).</a:t>
             </a:r>
             <a:endParaRPr lang="en-US" dirty="0"/>
           </a:p>
@@ -3254,7 +3254,7 @@
                   <a:srgbClr val="CADDDA"/>
                 </a:solidFill>
               </a:rPr>
-              <a:t>Performance requirements, golden-set accuracy and load testing of three local Ollama models for a financial-services complaints desk</a:t>
+              <a:t>Can an AI model running on a bank's own computers sort complaint tickets quickly and accurately enough? We tested three to find out.</a:t>
             </a:r>
             <a:endParaRPr lang="en-US" sz="1800" dirty="0"/>
           </a:p>
@@ -3305,7 +3305,7 @@
         <p:spPr>
           <a:xfrm>
             <a:off x="548640" y="4434840"/>
-            <a:ext cx="3291840" cy="310896"/>
+            <a:ext cx="3657600" cy="310896"/>
           </a:xfrm>
           <a:prstGeom prst="rect">
             <a:avLst/>
@@ -3326,7 +3326,7 @@
                   <a:schemeClr val="bg1"/>
                 </a:solidFill>
               </a:rPr>
-              <a:t>Zong Han</a:t>
+              <a:t>Chia ShuXian Natalie</a:t>
             </a:r>
             <a:pPr indent="0" marL="0">
               <a:buNone/>
@@ -3337,7 +3337,7 @@
                   <a:srgbClr val="CADDDA"/>
                 </a:solidFill>
               </a:rPr>
-              <a:t>   [student ID]</a:t>
+              <a:t>   2403237</a:t>
             </a:r>
             <a:endParaRPr lang="en-US" sz="1400" dirty="0"/>
           </a:p>
@@ -3352,7 +3352,7 @@
         <p:spPr>
           <a:xfrm>
             <a:off x="548640" y="4782312"/>
-            <a:ext cx="3291840" cy="310896"/>
+            <a:ext cx="3657600" cy="310896"/>
           </a:xfrm>
           <a:prstGeom prst="rect">
             <a:avLst/>
@@ -3373,7 +3373,7 @@
                   <a:schemeClr val="bg1"/>
                 </a:solidFill>
               </a:rPr>
-              <a:t>Ridwan</a:t>
+              <a:t>Chng Zong Han</a:t>
             </a:r>
             <a:pPr indent="0" marL="0">
               <a:buNone/>
@@ -3384,7 +3384,7 @@
                   <a:srgbClr val="CADDDA"/>
                 </a:solidFill>
               </a:rPr>
-              <a:t>   [student ID]</a:t>
+              <a:t>   2401892</a:t>
             </a:r>
             <a:endParaRPr lang="en-US" sz="1400" dirty="0"/>
           </a:p>
@@ -3399,7 +3399,7 @@
         <p:spPr>
           <a:xfrm>
             <a:off x="548640" y="5129784"/>
-            <a:ext cx="3291840" cy="310896"/>
+            <a:ext cx="3657600" cy="310896"/>
           </a:xfrm>
           <a:prstGeom prst="rect">
             <a:avLst/>
@@ -3420,7 +3420,7 @@
                   <a:schemeClr val="bg1"/>
                 </a:solidFill>
               </a:rPr>
-              <a:t>Tze Han</a:t>
+              <a:t>Kannan S/O Rajamohan</a:t>
             </a:r>
             <a:pPr indent="0" marL="0">
               <a:buNone/>
@@ -3431,7 +3431,7 @@
                   <a:srgbClr val="CADDDA"/>
                 </a:solidFill>
               </a:rPr>
-              <a:t>   [student ID]</a:t>
+              <a:t>   2401517</a:t>
             </a:r>
             <a:endParaRPr lang="en-US" sz="1400" dirty="0"/>
           </a:p>
@@ -3445,8 +3445,8 @@
         </p:nvSpPr>
         <p:spPr>
           <a:xfrm>
-            <a:off x="3931920" y="4434840"/>
-            <a:ext cx="3291840" cy="310896"/>
+            <a:off x="4251960" y="4434840"/>
+            <a:ext cx="3657600" cy="310896"/>
           </a:xfrm>
           <a:prstGeom prst="rect">
             <a:avLst/>
@@ -3467,7 +3467,7 @@
                   <a:schemeClr val="bg1"/>
                 </a:solidFill>
               </a:rPr>
-              <a:t>Kannan</a:t>
+              <a:t>Muhammad Ridwan Putra Jasni</a:t>
             </a:r>
             <a:pPr indent="0" marL="0">
               <a:buNone/>
@@ -3478,7 +3478,7 @@
                   <a:srgbClr val="CADDDA"/>
                 </a:solidFill>
               </a:rPr>
-              <a:t>   [student ID]</a:t>
+              <a:t>   2401684</a:t>
             </a:r>
             <a:endParaRPr lang="en-US" sz="1400" dirty="0"/>
           </a:p>
@@ -3492,8 +3492,8 @@
         </p:nvSpPr>
         <p:spPr>
           <a:xfrm>
-            <a:off x="3931920" y="4782312"/>
-            <a:ext cx="3291840" cy="310896"/>
+            <a:off x="4251960" y="4782312"/>
+            <a:ext cx="3657600" cy="310896"/>
           </a:xfrm>
           <a:prstGeom prst="rect">
             <a:avLst/>
@@ -3514,7 +3514,7 @@
                   <a:schemeClr val="bg1"/>
                 </a:solidFill>
               </a:rPr>
-              <a:t>Natalie</a:t>
+              <a:t>Tan Tze Han</a:t>
             </a:r>
             <a:pPr indent="0" marL="0">
               <a:buNone/>
@@ -3525,7 +3525,7 @@
                   <a:srgbClr val="CADDDA"/>
                 </a:solidFill>
               </a:rPr>
-              <a:t>   [student ID]</a:t>
+              <a:t>   2301483</a:t>
             </a:r>
             <a:endParaRPr lang="en-US" sz="1400" dirty="0"/>
           </a:p>
@@ -3751,7 +3751,7 @@
                   <a:srgbClr val="CADDDA"/>
                 </a:solidFill>
               </a:rPr>
-              <a:t>golden-set accuracy (161 / 195)</a:t>
+              <a:t>sorted correctly (161 of 195 tickets)</a:t>
             </a:r>
             <a:endParaRPr lang="en-US" sz="1300" dirty="0"/>
           </a:p>
@@ -3765,7 +3765,7 @@
         </p:nvSpPr>
         <p:spPr>
           <a:xfrm>
-            <a:off x="8321040" y="3611880"/>
+            <a:off x="8321040" y="3520440"/>
             <a:ext cx="3017520" cy="548640"/>
           </a:xfrm>
           <a:prstGeom prst="rect">
@@ -3804,8 +3804,8 @@
         </p:nvSpPr>
         <p:spPr>
           <a:xfrm>
-            <a:off x="8321040" y="4160520"/>
-            <a:ext cx="3017520" cy="274320"/>
+            <a:off x="8321040" y="4069080"/>
+            <a:ext cx="3017520" cy="502920"/>
           </a:xfrm>
           <a:prstGeom prst="rect">
             <a:avLst/>
@@ -3826,7 +3826,7 @@
                   <a:srgbClr val="CADDDA"/>
                 </a:solidFill>
               </a:rPr>
-              <a:t>POST /tickets p95 at peak load (limit 30 s)</a:t>
+              <a:t>95% of tickets sorted within this, in the busiest hour (target 30 s)</a:t>
             </a:r>
             <a:endParaRPr lang="en-US" sz="1300" dirty="0"/>
           </a:p>
@@ -3840,7 +3840,7 @@
         </p:nvSpPr>
         <p:spPr>
           <a:xfrm>
-            <a:off x="8321040" y="4572000"/>
+            <a:off x="8321040" y="4663440"/>
             <a:ext cx="3017520" cy="548640"/>
           </a:xfrm>
           <a:prstGeom prst="rect">
@@ -3862,7 +3862,7 @@
                   <a:srgbClr val="9BC1BC"/>
                 </a:solidFill>
               </a:rPr>
-              <a:t>Misses one requirement: Money transfer recall 66.7% vs 70%</a:t>
+              <a:t>Falls just short on one target: 66.7% of money-transfer tickets right (target 70%)</a:t>
             </a:r>
             <a:endParaRPr lang="en-US" sz="1200" dirty="0"/>
           </a:p>
@@ -3925,7 +3925,7 @@
                   <a:schemeClr val="tx2"/>
                 </a:solidFill>
               </a:rPr>
-              <a:t>Only the 7B model classifies usefully, and it misses one category</a:t>
+              <a:t>Only the large model sorts well, and it misses one category</a:t>
             </a:r>
             <a:endParaRPr lang="en-US" sz="3000" dirty="0"/>
           </a:p>
@@ -4659,7 +4659,7 @@
                   <a:schemeClr val="tx1"/>
                 </a:solidFill>
               </a:rPr>
-              <a:t>0.5B labels 155 of 195 tickets (79%) Credit card, whatever the content</a:t>
+              <a:t>Small Qwen puts 155 of 195 tickets (79%) in Credit card, whatever they say</a:t>
             </a:r>
             <a:endParaRPr lang="en-US" sz="1200" dirty="0"/>
           </a:p>
@@ -4677,7 +4677,7 @@
                   <a:schemeClr val="tx1"/>
                 </a:solidFill>
               </a:rPr>
-              <a:t>1B labels 121 (62%) Credit reporting; 0 of 24 Consumer loans right</a:t>
+              <a:t>Llama puts 121 (62%) in Credit reporting and gets none of the 24 consumer loans right</a:t>
             </a:r>
             <a:endParaRPr lang="en-US" sz="1200" dirty="0"/>
           </a:p>
@@ -4695,7 +4695,7 @@
                   <a:schemeClr val="tx1"/>
                 </a:solidFill>
               </a:rPr>
-              <a:t>7B sends 9 of 30 Money transfers to Bank account, the split our own labellers argued over most. It needs 21 of 30 correct for R5 and gets 20</a:t>
+              <a:t>Large Qwen puts 9 of 30 money transfers in Bank account, the pair our own team argued over most. It needed 21 of 30 for R5 and got 20</a:t>
             </a:r>
             <a:endParaRPr lang="en-US" sz="1200" dirty="0"/>
           </a:p>
@@ -4713,7 +4713,7 @@
                   <a:schemeClr val="tx1"/>
                 </a:solidFill>
               </a:rPr>
-              <a:t>7B also: 4 Credit reporting → Debt collection; 3 Consumer loan → Credit reporting</a:t>
+              <a:t>Its other slips: 4 credit-report tickets put in Debt collection; 3 consumer loans in Credit reporting</a:t>
             </a:r>
             <a:endParaRPr lang="en-US" sz="1200" dirty="0"/>
           </a:p>
@@ -4821,7 +4821,7 @@
                   <a:schemeClr val="tx2"/>
                 </a:solidFill>
               </a:rPr>
-              <a:t>Right about the bottleneck, wrong about its size</a:t>
+              <a:t>Right about the slow part, wrong about how slow</a:t>
             </a:r>
             <a:endParaRPr lang="en-US" sz="3000" dirty="0"/>
           </a:p>
@@ -4869,7 +4869,7 @@
                             <a:schemeClr val="bg1"/>
                           </a:solidFill>
                         </a:rPr>
-                        <a:t>We predicted</a:t>
+                        <a:t>We predicted (before testing)</a:t>
                       </a:r>
                       <a:endParaRPr lang="en-US" sz="1100" dirty="0"/>
                     </a:p>
@@ -5031,7 +5031,7 @@
                   </a:tcPr>
                 </a:tc>
               </a:tr>
-              <a:tr h="502920">
+              <a:tr h="548640">
                 <a:tc>
                   <a:txBody>
                     <a:bodyPr/>
@@ -5046,7 +5046,7 @@
                             <a:schemeClr val="tx1"/>
                           </a:solidFill>
                         </a:rPr>
-                        <a:t>Bottleneck: Ollama reading the prompt; Ollama ≥ 900% CPU, triage &lt; 10%</a:t>
+                        <a:t>Slow part: the model reading each ticket; it keeps ≥ 9 cores busy, our service &lt; 10% of one</a:t>
                       </a:r>
                       <a:endParaRPr lang="en-US" sz="1100" dirty="0"/>
                     </a:p>
@@ -5104,7 +5104,7 @@
                             <a:schemeClr val="tx1"/>
                           </a:solidFill>
                         </a:rPr>
-                        <a:t>Prompt = 82% of 7B model time; Ollama p99 1,040%, triage max 6.8%</a:t>
+                        <a:t>Reading = 82% of the large model's time; ~10.4 cores busy; our service ≤ 6.8%</a:t>
                       </a:r>
                       <a:endParaRPr lang="en-US" sz="1100" dirty="0"/>
                     </a:p>
@@ -5222,7 +5222,7 @@
                             <a:schemeClr val="tx1"/>
                           </a:solidFill>
                         </a:rPr>
-                        <a:t>Single-ticket p50: 0.8 / 0.9 / 6.1 s (0.5B / 1B / 7B)</a:t>
+                        <a:t>Typical time per ticket: 0.8 / 0.9 / 6.1 s (small Qwen / Llama / large Qwen)</a:t>
                       </a:r>
                       <a:endParaRPr lang="en-US" sz="1100" dirty="0"/>
                     </a:p>
@@ -5280,7 +5280,7 @@
                             <a:schemeClr val="tx1"/>
                           </a:solidFill>
                         </a:rPr>
-                        <a:t>0.40 / 0.46 / 2.84 s, about half</a:t>
+                        <a:t>0.40 / 0.46 / 2.84 s: about half</a:t>
                       </a:r>
                       <a:endParaRPr lang="en-US" sz="1100" dirty="0"/>
                     </a:p>
@@ -5398,7 +5398,7 @@
                             <a:schemeClr val="tx1"/>
                           </a:solidFill>
                         </a:rPr>
-                        <a:t>7B saturates near 9.4 /min; latency grows without bound at 9.6</a:t>
+                        <a:t>Large model overwhelmed near 9.4 /min; delays grow without end at 9.6</a:t>
                       </a:r>
                       <a:endParaRPr lang="en-US" sz="1100" dirty="0"/>
                     </a:p>
@@ -5456,7 +5456,7 @@
                             <a:schemeClr val="tx1"/>
                           </a:solidFill>
                         </a:rPr>
-                        <a:t>Stable at 9.6 /min, p95 17.3 s, 0 errors</a:t>
+                        <a:t>Kept up at 9.6 /min: 95% within 17.3 s, none failed</a:t>
                       </a:r>
                       <a:endParaRPr lang="en-US" sz="1100" dirty="0"/>
                     </a:p>
@@ -5559,7 +5559,7 @@
                   </a:tcPr>
                 </a:tc>
               </a:tr>
-              <a:tr h="365760">
+              <a:tr h="329184">
                 <a:tc>
                   <a:txBody>
                     <a:bodyPr/>
@@ -5750,7 +5750,7 @@
                             <a:schemeClr val="tx1"/>
                           </a:solidFill>
                         </a:rPr>
-                        <a:t>0.5B defaults to Credit reporting (&gt; 35% of answers)</a:t>
+                        <a:t>Small Qwen over-uses Credit reporting (&gt; 35% of answers)</a:t>
                       </a:r>
                       <a:endParaRPr lang="en-US" sz="1100" dirty="0"/>
                     </a:p>
@@ -5808,7 +5808,7 @@
                             <a:schemeClr val="tx1"/>
                           </a:solidFill>
                         </a:rPr>
-                        <a:t>Defaults to Credit card (79%)</a:t>
+                        <a:t>It over-uses Credit card instead (79%)</a:t>
                       </a:r>
                       <a:endParaRPr lang="en-US" sz="1100" dirty="0"/>
                     </a:p>
@@ -5926,7 +5926,7 @@
                             <a:schemeClr val="tx1"/>
                           </a:solidFill>
                         </a:rPr>
-                        <a:t>Hardest: Debt collection, Consumer loan; ≥ 25% of Money transfer → Bank account</a:t>
+                        <a:t>Hardest: Debt collection, Consumer loan; ≥ 25% of money transfers put in Bank account</a:t>
                       </a:r>
                       <a:endParaRPr lang="en-US" sz="1100" dirty="0"/>
                     </a:p>
@@ -5984,7 +5984,7 @@
                             <a:schemeClr val="tx1"/>
                           </a:solidFill>
                         </a:rPr>
-                        <a:t>Money transfer 66.7% (30% → Bank account), Consumer loan 70.8%; Debt collection 82.4%</a:t>
+                        <a:t>Money transfer 66.7% (30% put in Bank account), Consumer loan 70.8%; but Debt collection 82.4%</a:t>
                       </a:r>
                       <a:endParaRPr lang="en-US" sz="1100" dirty="0"/>
                     </a:p>
@@ -6102,7 +6102,7 @@
                             <a:schemeClr val="tx1"/>
                           </a:solidFill>
                         </a:rPr>
-                        <a:t>Search p95 &lt; 100 ms at peak</a:t>
+                        <a:t>95% of searches answered in under 0.1 s</a:t>
                       </a:r>
                       <a:endParaRPr lang="en-US" sz="1100" dirty="0"/>
                     </a:p>
@@ -6160,7 +6160,7 @@
                             <a:schemeClr val="tx1"/>
                           </a:solidFill>
                         </a:rPr>
-                        <a:t>0.22–0.46 s at JMeter (≤ 7 ms inside the service)</a:t>
+                        <a:t>0.22–0.46 s as JMeter sees it (under 7 ms inside the system)</a:t>
                       </a:r>
                       <a:endParaRPr lang="en-US" sz="1100" dirty="0"/>
                     </a:p>
@@ -6275,8 +6275,8 @@
         </p:nvSpPr>
         <p:spPr>
           <a:xfrm>
-            <a:off x="548640" y="4892040"/>
-            <a:ext cx="7269480" cy="1371600"/>
+            <a:off x="548640" y="5029200"/>
+            <a:ext cx="7269480" cy="1234440"/>
           </a:xfrm>
           <a:prstGeom prst="rect">
             <a:avLst/>
@@ -6297,7 +6297,7 @@
                   <a:schemeClr val="tx2"/>
                 </a:solidFill>
               </a:rPr>
-              <a:t>Why: </a:t>
+              <a:t>Why we were wrong: </a:t>
             </a:r>
             <a:pPr indent="0" marL="0">
               <a:buNone/>
@@ -6308,7 +6308,7 @@
                   <a:schemeClr val="tx1"/>
                 </a:solidFill>
               </a:rPr>
-              <a:t>latency was extrapolated from a prototype prompt with category definitions, ~170 tokens longer than the frozen one, so every time and the 7B capacity came out ~2× too slow. We underestimated how badly sub-1B models fail without definitions: each collapses onto a single label. Search time is network, not SQLite.</a:t>
+              <a:t>we estimated speed from an early trial whose instructions to the model were longer (about 170 extra word-pieces), so every time came out about twice too slow. We did not expect the small models, given only category names, to put nearly everything in one category. Search time is mostly Wi-Fi, not the database.</a:t>
             </a:r>
             <a:endParaRPr lang="en-US" sz="1200" dirty="0"/>
           </a:p>
@@ -6445,7 +6445,7 @@
                   <a:schemeClr val="bg1"/>
                 </a:solidFill>
               </a:rPr>
-              <a:t>Meets R1–R4: p95 6.1 s (limit 30), search 0.46 s (limit 1), 0 errors, 82.6% (bar 80)</a:t>
+              <a:t>Meets R1–R4: 95% of tickets in 6.1 s (target 30), searches in 0.46 s (target 1), no failures, 82.6% correct (target 80)</a:t>
             </a:r>
             <a:endParaRPr lang="en-US" sz="1200" dirty="0"/>
           </a:p>
@@ -6463,7 +6463,7 @@
                   <a:schemeClr val="bg1"/>
                 </a:solidFill>
               </a:rPr>
-              <a:t>Apache 2.0 licence passes C2; fits on one CPU server</a:t>
+              <a:t>Its licence (Apache 2.0) allows commercial use; runs on one standard server</a:t>
             </a:r>
             <a:endParaRPr lang="en-US" sz="1200" dirty="0"/>
           </a:p>
@@ -6481,7 +6481,7 @@
                   <a:schemeClr val="bg1"/>
                 </a:solidFill>
               </a:rPr>
-              <a:t>Small models fail R4 by 47–62 points. Under our position their speed does not matter</a:t>
+              <a:t>The small models are 47–62 points short on accuracy. We value correct routing over speed, so being faster does not save them</a:t>
             </a:r>
             <a:endParaRPr lang="en-US" sz="1200" dirty="0"/>
           </a:p>
@@ -6575,7 +6575,7 @@
                   <a:schemeClr val="bg1"/>
                 </a:solidFill>
               </a:rPr>
-              <a:t>No candidate meets every requirement. R5 fails for all three; for 7B, Money transfer reaches 66.7%, one ticket short of 70%. Until a prompt fix in A2, double-check tickets routed to Money transfer and Bank account.</a:t>
+              <a:t>No model meets every target. All three miss R5: the large model gets 66.7% of money transfers right, one ticket short of 70%. Until better instructions are tried in Assignment 2, staff should double-check tickets sorted into Money transfer or Bank account.</a:t>
             </a:r>
             <a:endParaRPr lang="en-US" sz="1100" dirty="0"/>
           </a:p>
@@ -7240,7 +7240,7 @@
                   <a:schemeClr val="tx2"/>
                 </a:solidFill>
               </a:rPr>
-              <a:t>One synchronous service in front of one CPU-only model server</a:t>
+              <a:t>Each ticket goes through one web service to one AI model</a:t>
             </a:r>
             <a:endParaRPr lang="en-US" sz="3000" dirty="0"/>
           </a:p>
@@ -7298,7 +7298,7 @@
                   <a:schemeClr val="accent1"/>
                 </a:solidFill>
               </a:rPr>
-              <a:t>LOAD GENERATOR</a:t>
+              <a:t>TEST TRAFFIC</a:t>
             </a:r>
             <a:endParaRPr lang="en-US" sz="1100" dirty="0"/>
           </a:p>
@@ -7370,7 +7370,7 @@
                   <a:schemeClr val="tx1"/>
                 </a:solidFill>
               </a:rPr>
-              <a:t>Apache JMeter 5.6.3, Open Model Thread Group. Plays the intake (POST) and the handlers (GET /search)</a:t>
+              <a:t>Apache JMeter 5.6.3 plays the bank: new complaints arriving, and staff searching past tickets</a:t>
             </a:r>
             <a:endParaRPr lang="en-US" sz="1200" dirty="0"/>
           </a:p>
@@ -7493,7 +7493,7 @@
                   <a:schemeClr val="accent1"/>
                 </a:solidFill>
               </a:rPr>
-              <a:t>SYSTEM UNDER TEST · MacBook Pro M5 · Docker</a:t>
+              <a:t>THE SYSTEM WE TESTED · MacBook Pro M5</a:t>
             </a:r>
             <a:endParaRPr lang="en-US" sz="1100" dirty="0"/>
           </a:p>
@@ -7551,7 +7551,7 @@
                   <a:schemeClr val="bg1"/>
                 </a:solidFill>
               </a:rPr>
-              <a:t>triage service (FastAPI, port 8000)</a:t>
+              <a:t>Triage web service (FastAPI)</a:t>
             </a:r>
             <a:endParaRPr lang="en-US" sz="1400" dirty="0"/>
           </a:p>
@@ -7587,7 +7587,7 @@
                   <a:srgbClr val="CADDDA"/>
                 </a:solidFill>
               </a:rPr>
-              <a:t>1 uvicorn worker · sync endpoints · writes one JSON log line per request</a:t>
+              <a:t>Receives each ticket, waits for the model's answer, and logs every request</a:t>
             </a:r>
             <a:endParaRPr lang="en-US" sz="1100" dirty="0"/>
           </a:p>
@@ -7669,7 +7669,7 @@
                   <a:schemeClr val="bg1"/>
                 </a:solidFill>
               </a:rPr>
-              <a:t>Ollama 0.35.1 (CPU only)</a:t>
+              <a:t>AI model server (Ollama)</a:t>
             </a:r>
             <a:endParaRPr lang="en-US" sz="1400" dirty="0"/>
           </a:p>
@@ -7705,7 +7705,7 @@
                   <a:schemeClr val="bg1"/>
                 </a:solidFill>
               </a:rPr>
-              <a:t>One model loaded · NUM_PARALLEL=1: one ticket at a time</a:t>
+              <a:t>Runs on the processor, no graphics card; one ticket at a time</a:t>
             </a:r>
             <a:endParaRPr lang="en-US" sz="1100" dirty="0"/>
           </a:p>
@@ -7787,7 +7787,7 @@
                   <a:schemeClr val="tx2"/>
                 </a:solidFill>
               </a:rPr>
-              <a:t>SQLite volume</a:t>
+              <a:t>Database</a:t>
             </a:r>
             <a:endParaRPr lang="en-US" sz="1300" dirty="0"/>
           </a:p>
@@ -7823,7 +7823,7 @@
                   <a:schemeClr val="tx1"/>
                 </a:solidFill>
               </a:rPr>
-              <a:t>tickets + category; starts empty</a:t>
+              <a:t>Sorted tickets; starts empty each run</a:t>
             </a:r>
             <a:endParaRPr lang="en-US" sz="1100" dirty="0"/>
           </a:p>
@@ -7917,7 +7917,7 @@
                   <a:schemeClr val="tx1"/>
                 </a:solidFill>
               </a:rPr>
-              <a:t>logs/service/*.jsonl, kept in git</a:t>
+              <a:t>One line per request, kept as evidence</a:t>
             </a:r>
             <a:endParaRPr lang="en-US" sz="1100" dirty="0"/>
           </a:p>
@@ -7956,7 +7956,7 @@
                 <a:ea typeface="Cambria" pitchFamily="34" charset="-122"/>
                 <a:cs typeface="Cambria" pitchFamily="34" charset="-120"/>
               </a:rPr>
-              <a:t>Endpoints</a:t>
+              <a:t>What the service offers</a:t>
             </a:r>
             <a:endParaRPr lang="en-US" sz="1800" dirty="0"/>
           </a:p>
@@ -8053,7 +8053,7 @@
                   <a:schemeClr val="tx1"/>
                 </a:solidFill>
               </a:rPr>
-              <a:t>Classifies one narrative into 1 of 7 categories (JSON-schema output), stores it, returns the category</a:t>
+              <a:t>Send in one complaint; the model picks 1 of 7 categories; the ticket is saved and its category returned</a:t>
             </a:r>
             <a:endParaRPr lang="en-US" sz="1100" dirty="0"/>
           </a:p>
@@ -8150,7 +8150,7 @@
                   <a:schemeClr val="tx1"/>
                 </a:solidFill>
               </a:rPr>
-              <a:t>Stored tickets whose text contains the query, newest first</a:t>
+              <a:t>Find saved tickets that contain a word, newest first</a:t>
             </a:r>
             <a:endParaRPr lang="en-US" sz="1100" dirty="0"/>
           </a:p>
@@ -8247,7 +8247,7 @@
                   <a:schemeClr val="tx1"/>
                 </a:solidFill>
               </a:rPr>
-              <a:t>Count of stored tickets per category</a:t>
+              <a:t>How many saved tickets are in each category</a:t>
             </a:r>
             <a:endParaRPr lang="en-US" sz="1100" dirty="0"/>
           </a:p>
@@ -8286,7 +8286,7 @@
                 <a:ea typeface="Cambria" pitchFamily="34" charset="-122"/>
                 <a:cs typeface="Cambria" pitchFamily="34" charset="-120"/>
               </a:rPr>
-              <a:t>Baseline as specified</a:t>
+              <a:t>Kept deliberately simple</a:t>
             </a:r>
             <a:endParaRPr lang="en-US" sz="1600" dirty="0"/>
           </a:p>
@@ -8326,7 +8326,7 @@
                   <a:schemeClr val="tx1"/>
                 </a:solidFill>
               </a:rPr>
-              <a:t>Synchronous: POST returns only after the model answers</a:t>
+              <a:t>The sender waits until the model has answered</a:t>
             </a:r>
             <a:endParaRPr lang="en-US" sz="1200" dirty="0"/>
           </a:p>
@@ -8344,7 +8344,7 @@
                   <a:schemeClr val="tx1"/>
                 </a:solidFill>
               </a:rPr>
-              <a:t>No caching: the same text is classified again</a:t>
+              <a:t>No shortcuts: a repeated ticket is sorted again</a:t>
             </a:r>
             <a:endParaRPr lang="en-US" sz="1200" dirty="0"/>
           </a:p>
@@ -8362,7 +8362,7 @@
                   <a:schemeClr val="tx1"/>
                 </a:solidFill>
               </a:rPr>
-              <a:t>No queuing in our code; Ollama's own FIFO is the only queue</a:t>
+              <a:t>No waiting line in our code; the model server has its own</a:t>
             </a:r>
             <a:endParaRPr lang="en-US" sz="1200" dirty="0"/>
           </a:p>
@@ -8380,7 +8380,7 @@
                   <a:schemeClr val="tx1"/>
                 </a:solidFill>
               </a:rPr>
-              <a:t>Search is a LIKE '%q%' scan; new SQLite connection per request</a:t>
+              <a:t>Search reads through every saved ticket (no index)</a:t>
             </a:r>
             <a:endParaRPr lang="en-US" sz="1200" dirty="0"/>
           </a:p>
@@ -8585,7 +8585,7 @@
                   <a:schemeClr val="tx1"/>
                 </a:solidFill>
               </a:rPr>
-              <a:t>in-scope complaints per half-year (Bank of Scotland plc, H2 2025)</a:t>
+              <a:t>complaints in 6 months at a large UK bank (Bank of Scotland, Jul–Dec 2025)</a:t>
             </a:r>
             <a:endParaRPr lang="en-US" sz="1100" dirty="0"/>
           </a:p>
@@ -8718,7 +8718,7 @@
                   <a:schemeClr val="tx1"/>
                 </a:solidFill>
               </a:rPr>
-              <a:t>per business day: ×2 for a year, ÷ 250 days</a:t>
+              <a:t>per working day: 86,719 × 2 = 173,438 a year, ÷ 250 working days</a:t>
             </a:r>
             <a:endParaRPr lang="en-US" sz="1100" dirty="0"/>
           </a:p>
@@ -8851,7 +8851,7 @@
                   <a:schemeClr val="tx1"/>
                 </a:solidFill>
               </a:rPr>
-              <a:t>average: 694 over 8 business hours</a:t>
+              <a:t>on average: 694 spread over an 8-hour working day</a:t>
             </a:r>
             <a:endParaRPr lang="en-US" sz="1100" dirty="0"/>
           </a:p>
@@ -8984,7 +8984,7 @@
                   <a:srgbClr val="CADDDA"/>
                 </a:solidFill>
               </a:rPr>
-              <a:t>peak hour carries 15% of the day: 104 tickets</a:t>
+              <a:t>in the busiest hour, which gets 15% of the day (104 tickets)</a:t>
             </a:r>
             <a:endParaRPr lang="en-US" sz="1100" dirty="0"/>
           </a:p>
@@ -9059,7 +9059,7 @@
                 <a:ea typeface="Cambria" pitchFamily="34" charset="-122"/>
                 <a:cs typeface="Cambria" pitchFamily="34" charset="-120"/>
               </a:rPr>
-              <a:t>Load levels tested (POST + search per minute)</a:t>
+              <a:t>Traffic levels we tested</a:t>
             </a:r>
             <a:endParaRPr lang="en-US" sz="1500" dirty="0"/>
           </a:p>
@@ -9291,7 +9291,7 @@
                             <a:schemeClr val="bg1"/>
                           </a:solidFill>
                         </a:rPr>
-                        <a:t>Basis</a:t>
+                        <a:t>Why</a:t>
                       </a:r>
                       <a:endParaRPr lang="en-US" sz="1200" dirty="0"/>
                     </a:p>
@@ -9528,7 +9528,7 @@
                             <a:schemeClr val="tx1"/>
                           </a:solidFill>
                         </a:rPr>
-                        <a:t>Average business hour</a:t>
+                        <a:t>A normal hour</a:t>
                       </a:r>
                       <a:endParaRPr lang="en-US" sz="1200" dirty="0"/>
                     </a:p>
@@ -9762,7 +9762,7 @@
                             <a:schemeClr val="tx1"/>
                           </a:solidFill>
                         </a:rPr>
-                        <a:t>Requirements must hold here</a:t>
+                        <a:t>Busiest hour: targets must be met here</a:t>
                       </a:r>
                       <a:endParaRPr lang="en-US" sz="1200" dirty="0"/>
                     </a:p>
@@ -9996,7 +9996,7 @@
                             <a:schemeClr val="tx1"/>
                           </a:solidFill>
                         </a:rPr>
-                        <a:t>2 × peak: unsized seasonal surges</a:t>
+                        <a:t>Double the peak: room for busy seasons</a:t>
                       </a:r>
                       <a:endParaRPr lang="en-US" sz="1200" dirty="0"/>
                     </a:p>
@@ -10079,7 +10079,7 @@
                   <a:schemeClr val="tx1"/>
                 </a:solidFill>
               </a:rPr>
-              <a:t>Searches: 2 per ticket handled (earlier complaints + similar cases). ESTIMATED: no published figure</a:t>
+              <a:t>Searches: we assume staff search twice per ticket (the customer's past complaints, similar cases). An estimate: no published figure exists</a:t>
             </a:r>
             <a:endParaRPr lang="en-US" sz="1200" dirty="0"/>
           </a:p>
@@ -10097,7 +10097,7 @@
                   <a:schemeClr val="tx1"/>
                 </a:solidFill>
               </a:rPr>
-              <a:t>Every complaint counted as a ticket, phone included; out-of-hours folded into business hours. Both overstate load</a:t>
+              <a:t>We count phone complaints as tickets too, and move out-of-hours ones into office hours. Both make our test harder than reality</a:t>
             </a:r>
             <a:endParaRPr lang="en-US" sz="1200" dirty="0"/>
           </a:p>
@@ -10153,7 +10153,7 @@
                   <a:schemeClr val="tx1"/>
                 </a:solidFill>
               </a:rPr>
-              <a:t>Median 797 chars / 144 words; p95 1,780 chars (2.2 × median)</a:t>
+              <a:t>Each bar is the length that share of tickets stays under: half are under 797 characters (~144 words), 95% under 1,780</a:t>
             </a:r>
             <a:endParaRPr lang="en-US" sz="1200" dirty="0"/>
           </a:p>
@@ -10171,7 +10171,7 @@
                   <a:schemeClr val="tx1"/>
                 </a:solidFill>
               </a:rPr>
-              <a:t>Max 2,000 chars + 395-char prompt fits num_ctx 4,096: nothing truncated (max 617 prompt tokens logged)</a:t>
+              <a:t>Even the longest (2,000 characters) plus our instructions fits in what the model reads at once, so no ticket is cut short</a:t>
             </a:r>
             <a:endParaRPr lang="en-US" sz="1200" dirty="0"/>
           </a:p>
@@ -10294,11 +10294,11 @@
         <p:spPr>
           <a:xfrm>
             <a:off x="548640" y="1280160"/>
-            <a:ext cx="11094415" cy="749808"/>
+            <a:ext cx="11094415" cy="822960"/>
           </a:xfrm>
           <a:prstGeom prst="roundRect">
             <a:avLst>
-              <a:gd name="adj" fmla="val 9756"/>
+              <a:gd name="adj" fmla="val 8889"/>
             </a:avLst>
           </a:prstGeom>
           <a:solidFill>
@@ -10316,7 +10316,7 @@
         <p:spPr>
           <a:xfrm>
             <a:off x="777240" y="1325880"/>
-            <a:ext cx="10637215" cy="658368"/>
+            <a:ext cx="10637215" cy="731520"/>
           </a:xfrm>
           <a:prstGeom prst="rect">
             <a:avLst/>
@@ -10348,7 +10348,7 @@
                   <a:schemeClr val="bg1"/>
                 </a:solidFill>
               </a:rPr>
-              <a:t>a misrouted ticket costs more than a slow one. It must be noticed, re-read and re-routed by a second team. A 30 s classification changes nothing for a complaint a person answers over hours or days.</a:t>
+              <a:t>sending a ticket to the wrong team costs more than sorting it slowly. A wrong ticket must be spotted, re-read and passed on by another team. Waiting 30 seconds instead of 5 makes no difference to a complaint a person answers over hours or days.</a:t>
             </a:r>
             <a:endParaRPr lang="en-US" sz="1300" dirty="0"/>
           </a:p>
@@ -10369,7 +10369,7 @@
           </p:nvPr>
         </p:nvGraphicFramePr>
         <p:xfrm>
-          <a:off x="548640" y="2240280"/>
+          <a:off x="548640" y="2286000"/>
           <a:ext cx="11094415" cy="914400"/>
         </p:xfrm>
         <a:graphic>
@@ -10379,8 +10379,8 @@
               <a:tblGrid>
                 <a:gridCol w="548640"/>
                 <a:gridCol w="3246120"/>
-                <a:gridCol w="3017520"/>
-                <a:gridCol w="4279392"/>
+                <a:gridCol w="2834640"/>
+                <a:gridCol w="4462272"/>
               </a:tblGrid>
               <a:tr h="329184">
                 <a:tc>
@@ -10458,7 +10458,7 @@
                             <a:schemeClr val="bg1"/>
                           </a:solidFill>
                         </a:rPr>
-                        <a:t>Requirement (testable)</a:t>
+                        <a:t>Target</a:t>
                       </a:r>
                       <a:endParaRPr lang="en-US" sz="1200" dirty="0"/>
                     </a:p>
@@ -10519,7 +10519,7 @@
                             <a:schemeClr val="bg1"/>
                           </a:solidFill>
                         </a:rPr>
-                        <a:t>Load condition</a:t>
+                        <a:t>Tested under</a:t>
                       </a:r>
                       <a:endParaRPr lang="en-US" sz="1200" dirty="0"/>
                     </a:p>
@@ -10628,7 +10628,7 @@
                   </a:tcPr>
                 </a:tc>
               </a:tr>
-              <a:tr h="566928">
+              <a:tr h="603504">
                 <a:tc>
                   <a:txBody>
                     <a:bodyPr/>
@@ -10701,7 +10701,7 @@
                             <a:schemeClr val="tx1"/>
                           </a:solidFill>
                         </a:rPr>
-                        <a:t>POST /tickets p95 ≤ 30 s</a:t>
+                        <a:t>95% of tickets sorted within 30 s</a:t>
                       </a:r>
                       <a:endParaRPr lang="en-US" sz="1200" dirty="0"/>
                     </a:p>
@@ -10759,7 +10759,7 @@
                             <a:schemeClr val="tx1"/>
                           </a:solidFill>
                         </a:rPr>
-                        <a:t>Peak 1.73 tickets/min, 10 min, 3 runs</a:t>
+                        <a:t>Busiest hour: 1.73 tickets/min for 10 min, 3 runs</a:t>
                       </a:r>
                       <a:endParaRPr lang="en-US" sz="1200" dirty="0"/>
                     </a:p>
@@ -10817,7 +10817,7 @@
                             <a:schemeClr val="tx1"/>
                           </a:solidFill>
                         </a:rPr>
-                        <a:t>At peak a ticket arrives every ~35 s; slower than that and a one-at-a-time queue never clears</a:t>
+                        <a:t>At peak a ticket arrives about every 35 s. Sorting slower than that means tickets pile up</a:t>
                       </a:r>
                       <a:endParaRPr lang="en-US" sz="1200" dirty="0"/>
                     </a:p>
@@ -10862,7 +10862,7 @@
                   </a:tcPr>
                 </a:tc>
               </a:tr>
-              <a:tr h="566928">
+              <a:tr h="603504">
                 <a:tc>
                   <a:txBody>
                     <a:bodyPr/>
@@ -10935,7 +10935,7 @@
                             <a:schemeClr val="tx1"/>
                           </a:solidFill>
                         </a:rPr>
-                        <a:t>GET /search p95 ≤ 1 s</a:t>
+                        <a:t>95% of searches answered within 1 s</a:t>
                       </a:r>
                       <a:endParaRPr lang="en-US" sz="1200" dirty="0"/>
                     </a:p>
@@ -10993,7 +10993,7 @@
                             <a:schemeClr val="tx1"/>
                           </a:solidFill>
                         </a:rPr>
-                        <a:t>Mixed: 1.73 tickets + 3.5 searches/min, 10 min</a:t>
+                        <a:t>Busiest hour plus 3.5 searches/min, 10 min</a:t>
                       </a:r>
                       <a:endParaRPr lang="en-US" sz="1200" dirty="0"/>
                     </a:p>
@@ -11051,7 +11051,7 @@
                             <a:schemeClr val="tx1"/>
                           </a:solidFill>
                         </a:rPr>
-                        <a:t>A handler waits at the screen; ~1 s keeps their flow of thought unbroken [7]</a:t>
+                        <a:t>Staff wait at the screen; about 1 s keeps their train of thought [7]</a:t>
                       </a:r>
                       <a:endParaRPr lang="en-US" sz="1200" dirty="0"/>
                     </a:p>
@@ -11096,7 +11096,7 @@
                   </a:tcPr>
                 </a:tc>
               </a:tr>
-              <a:tr h="566928">
+              <a:tr h="603504">
                 <a:tc>
                   <a:txBody>
                     <a:bodyPr/>
@@ -11169,7 +11169,7 @@
                             <a:schemeClr val="tx1"/>
                           </a:solidFill>
                         </a:rPr>
-                        <a:t>Throughput ≥ 104 classified/hour (1.73/min), errors ≤ 1%, latency not growing</a:t>
+                        <a:t>Keeps up: ≥ 104 tickets sorted an hour, ≤ 1% failures, delays not growing</a:t>
                       </a:r>
                       <a:endParaRPr lang="en-US" sz="1200" dirty="0"/>
                     </a:p>
@@ -11227,7 +11227,7 @@
                             <a:schemeClr val="tx1"/>
                           </a:solidFill>
                         </a:rPr>
-                        <a:t>Peak 1.73 tickets/min, 10 min, 3 runs</a:t>
+                        <a:t>Busiest hour, 10 min, 3 runs</a:t>
                       </a:r>
                       <a:endParaRPr lang="en-US" sz="1200" dirty="0"/>
                     </a:p>
@@ -11285,7 +11285,7 @@
                             <a:schemeClr val="tx1"/>
                           </a:solidFill>
                         </a:rPr>
-                        <a:t>Peak-hour volume; throughput below arrivals means a growing backlog</a:t>
+                        <a:t>104 is the busiest hour's volume; sorting fewer means a growing backlog</a:t>
                       </a:r>
                       <a:endParaRPr lang="en-US" sz="1200" dirty="0"/>
                     </a:p>
@@ -11330,7 +11330,7 @@
                   </a:tcPr>
                 </a:tc>
               </a:tr>
-              <a:tr h="566928">
+              <a:tr h="603504">
                 <a:tc>
                   <a:txBody>
                     <a:bodyPr/>
@@ -11403,7 +11403,7 @@
                             <a:schemeClr val="tx1"/>
                           </a:solidFill>
                         </a:rPr>
-                        <a:t>Overall accuracy ≥ 80%</a:t>
+                        <a:t>At least 80% of tickets sorted correctly</a:t>
                       </a:r>
                       <a:endParaRPr lang="en-US" sz="1200" dirty="0"/>
                     </a:p>
@@ -11461,7 +11461,7 @@
                             <a:schemeClr val="tx1"/>
                           </a:solidFill>
                         </a:rPr>
-                        <a:t>195-ticket golden set, one pass</a:t>
+                        <a:t>Our 195 hand-checked tickets, once each</a:t>
                       </a:r>
                       <a:endParaRPr lang="en-US" sz="1200" dirty="0"/>
                     </a:p>
@@ -11519,7 +11519,7 @@
                             <a:schemeClr val="tx1"/>
                           </a:solidFill>
                         </a:rPr>
-                        <a:t>Our labellers agreed on 78–85% before discussion: the model must match one trained human</a:t>
+                        <a:t>Our own team agreed with each other on 78–85% of tickets: the model should do as well as one trained person</a:t>
                       </a:r>
                       <a:endParaRPr lang="en-US" sz="1200" dirty="0"/>
                     </a:p>
@@ -11564,7 +11564,7 @@
                   </a:tcPr>
                 </a:tc>
               </a:tr>
-              <a:tr h="566928">
+              <a:tr h="603504">
                 <a:tc>
                   <a:txBody>
                     <a:bodyPr/>
@@ -11637,7 +11637,7 @@
                             <a:schemeClr val="tx1"/>
                           </a:solidFill>
                         </a:rPr>
-                        <a:t>Every category recall ≥ 70%</a:t>
+                        <a:t>At least 70% correct in every category</a:t>
                       </a:r>
                       <a:endParaRPr lang="en-US" sz="1200" dirty="0"/>
                     </a:p>
@@ -11695,7 +11695,7 @@
                             <a:schemeClr val="tx1"/>
                           </a:solidFill>
                         </a:rPr>
-                        <a:t>Golden set, per category</a:t>
+                        <a:t>Each category of the 195</a:t>
                       </a:r>
                       <a:endParaRPr lang="en-US" sz="1200" dirty="0"/>
                     </a:p>
@@ -11753,7 +11753,7 @@
                             <a:schemeClr val="tx1"/>
                           </a:solidFill>
                         </a:rPr>
-                        <a:t>Smallest classes have 17–18 tickets (~6 points per error), so the bar sits below R4</a:t>
+                        <a:t>Small categories have only 17–18 tickets, so one wrong ticket costs ~6 points. A lower bar avoids failing a model over 1–2 tickets</a:t>
                       </a:r>
                       <a:endParaRPr lang="en-US" sz="1200" dirty="0"/>
                     </a:p>
@@ -11810,12 +11810,12 @@
         </p:nvSpPr>
         <p:spPr>
           <a:xfrm>
-            <a:off x="548640" y="5760720"/>
-            <a:ext cx="11094415" cy="502920"/>
+            <a:off x="548640" y="5806440"/>
+            <a:ext cx="11094415" cy="457200"/>
           </a:xfrm>
           <a:prstGeom prst="roundRect">
             <a:avLst>
-              <a:gd name="adj" fmla="val 14545"/>
+              <a:gd name="adj" fmla="val 16000"/>
             </a:avLst>
           </a:prstGeom>
           <a:solidFill>
@@ -11832,8 +11832,8 @@
         </p:nvSpPr>
         <p:spPr>
           <a:xfrm>
-            <a:off x="777240" y="5760720"/>
-            <a:ext cx="10637215" cy="502920"/>
+            <a:off x="777240" y="5806440"/>
+            <a:ext cx="10637215" cy="457200"/>
           </a:xfrm>
           <a:prstGeom prst="rect">
             <a:avLst/>
@@ -11854,7 +11854,7 @@
                   <a:schemeClr val="tx2"/>
                 </a:solidFill>
               </a:rPr>
-              <a:t>Constraints.  C1: </a:t>
+              <a:t>Client rules.  C1: </a:t>
             </a:r>
             <a:pPr indent="0" marL="0">
               <a:buNone/>
@@ -11865,7 +11865,7 @@
                   <a:schemeClr val="tx1"/>
                 </a:solidFill>
               </a:rPr>
-              <a:t>local Ollama on CPU only, no public API.   </a:t>
+              <a:t>the model runs on the bank's own computers, without graphics cards; no outside AI service.   </a:t>
             </a:r>
             <a:pPr indent="0" marL="0">
               <a:buNone/>
@@ -11887,7 +11887,7 @@
                   <a:schemeClr val="tx1"/>
                 </a:solidFill>
               </a:rPr>
-              <a:t>the model's licence must allow the bank's commercial use.</a:t>
+              <a:t>the model's licence must allow commercial use.</a:t>
             </a:r>
             <a:endParaRPr lang="en-US" sz="1200" dirty="0"/>
           </a:p>
@@ -11995,7 +11995,7 @@
                   <a:schemeClr val="tx2"/>
                 </a:solidFill>
               </a:rPr>
-              <a:t>Three candidates span two size classes and 15× in parameters</a:t>
+              <a:t>We tested three models, from small and fast to 15 times larger</a:t>
             </a:r>
             <a:endParaRPr lang="en-US" sz="3000" dirty="0"/>
           </a:p>
@@ -12073,7 +12073,7 @@
                   <a:schemeClr val="accent1"/>
                 </a:solidFill>
               </a:rPr>
-              <a:t>SMALL  · &lt; 1B</a:t>
+              <a:t>SMALL</a:t>
             </a:r>
             <a:endParaRPr lang="en-US" sz="1100" dirty="0"/>
           </a:p>
@@ -12148,7 +12148,7 @@
                   <a:schemeClr val="tx1"/>
                 </a:solidFill>
               </a:rPr>
-              <a:t>494M params · Q4_K_M · 398 MB</a:t>
+              <a:t>0.5 billion parameters · 398 MB</a:t>
             </a:r>
             <a:endParaRPr lang="en-US" sz="1200" dirty="0"/>
           </a:p>
@@ -12231,7 +12231,7 @@
                   <a:schemeClr val="accent5"/>
                 </a:solidFill>
               </a:rPr>
-              <a:t>Fastest baseline; same family as the 7B, so size is the only variable</a:t>
+              <a:t>Fastest. Same maker as the large one, so only size differs</a:t>
             </a:r>
             <a:endParaRPr lang="en-US" sz="1200" dirty="0"/>
           </a:p>
@@ -12309,7 +12309,7 @@
                   <a:schemeClr val="accent1"/>
                 </a:solidFill>
               </a:rPr>
-              <a:t>SMALL  · ~1B</a:t>
+              <a:t>SMALL</a:t>
             </a:r>
             <a:endParaRPr lang="en-US" sz="1100" dirty="0"/>
           </a:p>
@@ -12384,7 +12384,7 @@
                   <a:schemeClr val="tx1"/>
                 </a:solidFill>
               </a:rPr>
-              <a:t>1.2B params · Q4_K_M · 808 MB</a:t>
+              <a:t>1.2 billion parameters · 808 MB</a:t>
             </a:r>
             <a:endParaRPr lang="en-US" sz="1200" dirty="0"/>
           </a:p>
@@ -12467,7 +12467,7 @@
                   <a:schemeClr val="accent5"/>
                 </a:solidFill>
               </a:rPr>
-              <a:t>A second family in the small class: does training matter as much as size?</a:t>
+              <a:t>A small model from a different maker: does how it was trained matter as much as size?</a:t>
             </a:r>
             <a:endParaRPr lang="en-US" sz="1200" dirty="0"/>
           </a:p>
@@ -12545,7 +12545,7 @@
                   <a:schemeClr val="accent1"/>
                 </a:solidFill>
               </a:rPr>
-              <a:t>LARGE  · ~7B</a:t>
+              <a:t>LARGE</a:t>
             </a:r>
             <a:endParaRPr lang="en-US" sz="1100" dirty="0"/>
           </a:p>
@@ -12620,7 +12620,7 @@
                   <a:schemeClr val="tx1"/>
                 </a:solidFill>
               </a:rPr>
-              <a:t>7.6B params · Q4_K_M · 4.7 GB</a:t>
+              <a:t>7.6 billion parameters · 4.7 GB</a:t>
             </a:r>
             <a:endParaRPr lang="en-US" sz="1200" dirty="0"/>
           </a:p>
@@ -12703,7 +12703,7 @@
                   <a:schemeClr val="accent5"/>
                 </a:solidFill>
               </a:rPr>
-              <a:t>Largest that fits the 9.7 GiB Docker memory budget; expected most accurate</a:t>
+              <a:t>The largest that fits our test machine's memory; expected to be most accurate</a:t>
             </a:r>
             <a:endParaRPr lang="en-US" sz="1200" dirty="0"/>
           </a:p>
@@ -12739,7 +12739,7 @@
                   <a:schemeClr val="tx2"/>
                 </a:solidFill>
               </a:rPr>
-              <a:t>Pins (full SHA-256 digests as installed; checked with pull_models.py --check before every session)</a:t>
+              <a:t>Exact versions tested: each model's unique fingerprint (digest), checked before every test session</a:t>
             </a:r>
             <a:endParaRPr lang="en-US" sz="1300" dirty="0"/>
           </a:p>
@@ -13457,7 +13457,7 @@
                   <a:schemeClr val="accent5"/>
                 </a:solidFill>
               </a:rPr>
-              <a:t>All Q4_K_M, so quantisation is held constant. qwen2.5:3b was in the frozen four-model set but was not measured: its Qwen Research licence is non-commercial and fails C2.</a:t>
+              <a:t>All three are compressed the same way (Q4_K_M), so size is the only difference. A fourth, qwen2.5:3b, was planned but not tested: its licence bans commercial use (fails C2).</a:t>
             </a:r>
             <a:endParaRPr lang="en-US" sz="1200" dirty="0"/>
           </a:p>
@@ -13565,7 +13565,7 @@
                   <a:schemeClr val="tx2"/>
                 </a:solidFill>
               </a:rPr>
-              <a:t>195 golden tickets, labelled twice and frozen before testing</a:t>
+              <a:t>195 tickets labelled twice by hand, then locked</a:t>
             </a:r>
             <a:endParaRPr lang="en-US" sz="3000" dirty="0"/>
           </a:p>
@@ -13662,7 +13662,7 @@
                   <a:schemeClr val="accent1"/>
                 </a:solidFill>
               </a:rPr>
-              <a:t>Group A, rows 3000–3099</a:t>
+              <a:t>Group A agreement (2 people)</a:t>
             </a:r>
             <a:endParaRPr lang="en-US" sz="1300" dirty="0"/>
           </a:p>
@@ -13698,7 +13698,7 @@
                   <a:schemeClr val="tx1"/>
                 </a:solidFill>
               </a:rPr>
-              <a:t>Cohen's kappa, 2 labellers (78% raw agreement)</a:t>
+              <a:t>Cohen's kappa: 0 = chance, 1 = perfect. Same label on 78% of tickets</a:t>
             </a:r>
             <a:endParaRPr lang="en-US" sz="1100" dirty="0"/>
           </a:p>
@@ -13795,7 +13795,7 @@
                   <a:schemeClr val="accent1"/>
                 </a:solidFill>
               </a:rPr>
-              <a:t>Group B, rows 3100–3199</a:t>
+              <a:t>Group B agreement (3 people)</a:t>
             </a:r>
             <a:endParaRPr lang="en-US" sz="1300" dirty="0"/>
           </a:p>
@@ -13831,7 +13831,7 @@
                   <a:schemeClr val="tx1"/>
                 </a:solidFill>
               </a:rPr>
-              <a:t>Fleiss' kappa, 3 labellers (pairwise Cohen 0.745–0.826)</a:t>
+              <a:t>Fleiss' kappa. Both groups count as substantial agreement</a:t>
             </a:r>
             <a:endParaRPr lang="en-US" sz="1100" dirty="0"/>
           </a:p>
@@ -13928,7 +13928,7 @@
                   <a:schemeClr val="accent1"/>
                 </a:solidFill>
               </a:rPr>
-              <a:t>disagreements, all recorded</a:t>
+              <a:t>disagreements, each discussed</a:t>
             </a:r>
             <a:endParaRPr lang="en-US" sz="1300" dirty="0"/>
           </a:p>
@@ -13964,7 +13964,7 @@
                   <a:schemeClr val="tx1"/>
                 </a:solidFill>
               </a:rPr>
-              <a:t>44 resolved to a category · 5 excluded (no identifiable product)</a:t>
+              <a:t>44 settled on a category · 5 dropped: no product named</a:t>
             </a:r>
             <a:endParaRPr lang="en-US" sz="1100" dirty="0"/>
           </a:p>
@@ -14003,7 +14003,7 @@
                 <a:ea typeface="Cambria" pitchFamily="34" charset="-122"/>
                 <a:cs typeface="Cambria" pitchFamily="34" charset="-120"/>
               </a:rPr>
-              <a:t>Protocol revisions</a:t>
+              <a:t>How our labelling rules changed</a:t>
             </a:r>
             <a:endParaRPr lang="en-US" sz="1500" dirty="0"/>
           </a:p>
@@ -14118,7 +14118,7 @@
                   <a:schemeClr val="tx1"/>
                 </a:solidFill>
               </a:rPr>
-              <a:t>Definitions for 7 categories; tie-break: the product the complaint is mainly about</a:t>
+              <a:t>First rules: a definition per category; if unsure, pick the product the complaint is mainly about</a:t>
             </a:r>
             <a:endParaRPr lang="en-US" sz="1100" dirty="0"/>
           </a:p>
@@ -14210,7 +14210,7 @@
                   <a:schemeClr val="tx1"/>
                 </a:solidFill>
               </a:rPr>
-              <a:t>From 16 Group A rows: decide Credit reporting vs Debt collection by who the complaint is against; student loans → Consumer loan; bank-account fraud → Bank account</a:t>
+              <a:t>After 16 disputed tickets: credit report vs debt collector decided by who the complaint is against; student loans count as Consumer loan</a:t>
             </a:r>
             <a:endParaRPr lang="en-US" sz="1100" dirty="0"/>
           </a:p>
@@ -14302,7 +14302,7 @@
                   <a:schemeClr val="tx1"/>
                 </a:solidFill>
               </a:rPr>
-              <a:t>From 12 Group B rows: prepaid cards and crypto → Money transfer; scams follow the product the money left through; when to EXCLUDE</a:t>
+              <a:t>After 12 more: prepaid cards and crypto count as Money transfer; scams go with where the money left from; when to drop a ticket</a:t>
             </a:r>
             <a:endParaRPr lang="en-US" sz="1100" dirty="0"/>
           </a:p>
@@ -14365,7 +14365,7 @@
                   <a:schemeClr val="accent1"/>
                 </a:solidFill>
               </a:rPr>
-              <a:t>Same situation, two answers (3025 vs 3072, rule v0.2)</a:t>
+              <a:t>Same problem, two answers (tickets 3025 and 3072)</a:t>
             </a:r>
             <a:endParaRPr lang="en-US" sz="1300" dirty="0"/>
           </a:p>
@@ -14401,7 +14401,7 @@
                   <a:schemeClr val="tx1"/>
                 </a:solidFill>
               </a:rPr>
-              <a:t>Both: a collection account on a credit report. 3025 demands TransUnion delete it → Credit reporting. 3072 says Midland, the collector, never proved the debt → Debt collection.</a:t>
+              <a:t>Both are about a debt showing on a credit report. 3025 asks the credit agency (TransUnion) to remove it → Credit reporting. 3072 says the debt collector (Midland) never proved the debt → Debt collection.</a:t>
             </a:r>
             <a:endParaRPr lang="en-US" sz="1200" dirty="0"/>
           </a:p>
@@ -14464,7 +14464,7 @@
                   <a:schemeClr val="accent1"/>
                 </a:solidFill>
               </a:rPr>
-              <a:t>A rule overturning the majority (3141)</a:t>
+              <a:t>A rule overruling the majority (ticket 3141)</a:t>
             </a:r>
             <a:endParaRPr lang="en-US" sz="1300" dirty="0"/>
           </a:p>
@@ -14500,7 +14500,7 @@
                   <a:schemeClr val="tx1"/>
                 </a:solidFill>
               </a:rPr>
-              <a:t>2 of 3 labellers chose Credit reporting: the person wants a repossession removed. The request is to Ally Financial, the auto lender, so v0.2 makes it Consumer loan.</a:t>
+              <a:t>2 of 3 labellers chose Credit reporting: the person wants a car repossession off their report. But they are asking the car lender (Ally Financial), not a credit agency, so the rule makes it Consumer loan.</a:t>
             </a:r>
             <a:endParaRPr lang="en-US" sz="1200" dirty="0"/>
           </a:p>
@@ -14608,7 +14608,7 @@
                   <a:schemeClr val="tx2"/>
                 </a:solidFill>
               </a:rPr>
-              <a:t>Two Macs over Wi-Fi; model CPU time is what scales</a:t>
+              <a:t>Our test set-up, and how it carries over to the bank</a:t>
             </a:r>
             <a:endParaRPr lang="en-US" sz="3000" dirty="0"/>
           </a:p>
@@ -14666,7 +14666,7 @@
                   <a:srgbClr val="9BC1BC"/>
                 </a:solidFill>
               </a:rPr>
-              <a:t>SYSTEM UNDER TEST: triage + Ollama</a:t>
+              <a:t>MACHINE RUNNING THE SYSTEM</a:t>
             </a:r>
             <a:endParaRPr lang="en-US" sz="1100" dirty="0"/>
           </a:p>
@@ -14706,7 +14706,7 @@
                   <a:schemeClr val="bg1"/>
                 </a:solidFill>
               </a:rPr>
-              <a:t>MacBook Pro (Mac17,2), Apple M5, 10 cores (4 P + 6 E), 16 GB</a:t>
+              <a:t>MacBook Pro, Apple M5 chip, 10 cores, 16 GB memory</a:t>
             </a:r>
             <a:endParaRPr lang="en-US" sz="1300" dirty="0"/>
           </a:p>
@@ -14724,7 +14724,7 @@
                   <a:schemeClr val="bg1"/>
                 </a:solidFill>
               </a:rPr>
-              <a:t>macOS 26.6.2 · Docker 29.8.2, VM with 10 CPUs and 9.7 GiB</a:t>
+              <a:t>macOS 26.6.2; Docker 29.8.2 given 10 cores and 9.7 GiB</a:t>
             </a:r>
             <a:endParaRPr lang="en-US" sz="1300" dirty="0"/>
           </a:p>
@@ -14742,7 +14742,7 @@
                   <a:schemeClr val="bg1"/>
                 </a:solidFill>
               </a:rPr>
-              <a:t>Ollama 0.35.1, CPU only (ollama ps: 100% CPU)</a:t>
+              <a:t>Ollama 0.35.1, processor only (no graphics card)</a:t>
             </a:r>
             <a:endParaRPr lang="en-US" sz="1300" dirty="0"/>
           </a:p>
@@ -14760,7 +14760,7 @@
                   <a:schemeClr val="bg1"/>
                 </a:solidFill>
               </a:rPr>
-              <a:t>NUM_PARALLEL=1 · num_ctx 4096 · temperature 0 · seed 42</a:t>
+              <a:t>One ticket at a time; fixed settings so answers repeat exactly</a:t>
             </a:r>
             <a:endParaRPr lang="en-US" sz="1300" dirty="0"/>
           </a:p>
@@ -14878,7 +14878,7 @@
                   <a:schemeClr val="accent1"/>
                 </a:solidFill>
               </a:rPr>
-              <a:t>LOAD GENERATOR: a separate machine</a:t>
+              <a:t>MACHINE SENDING TEST TRAFFIC</a:t>
             </a:r>
             <a:endParaRPr lang="en-US" sz="1100" dirty="0"/>
           </a:p>
@@ -14936,7 +14936,7 @@
                   <a:schemeClr val="tx1"/>
                 </a:solidFill>
               </a:rPr>
-              <a:t>Java 17.0.17 · Apache JMeter 5.6.3, non-GUI mode</a:t>
+              <a:t>Apache JMeter 5.6.3 (Java 17.0.17), run without its on-screen interface</a:t>
             </a:r>
             <a:endParaRPr lang="en-US" sz="1300" dirty="0"/>
           </a:p>
@@ -14954,7 +14954,7 @@
                   <a:schemeClr val="tx1"/>
                 </a:solidFill>
               </a:rPr>
-              <a:t>Reaches the SUT at 172.20.10.2:8000 over Wi-Fi</a:t>
+              <a:t>Connects over Wi-Fi to the system at 172.20.10.2</a:t>
             </a:r>
             <a:endParaRPr lang="en-US" sz="1300" dirty="0"/>
           </a:p>
@@ -14972,7 +14972,7 @@
                   <a:schemeClr val="tx1"/>
                 </a:solidFill>
               </a:rPr>
-              <a:t>Confirmed separate: different OS build from the SUT (26.5 vs 26.6.2); every JMeter log targets host 172.20.10.2</a:t>
+              <a:t>Proof it is separate: a different macOS version, and every JMeter log points at the other machine</a:t>
             </a:r>
             <a:endParaRPr lang="en-US" sz="1300" dirty="0"/>
           </a:p>
@@ -15011,7 +15011,7 @@
                 <a:ea typeface="Cambria" pitchFamily="34" charset="-122"/>
                 <a:cs typeface="Cambria" pitchFamily="34" charset="-120"/>
               </a:rPr>
-              <a:t>How results scale to the client's servers</a:t>
+              <a:t>How results carry over to the bank's servers</a:t>
             </a:r>
             <a:endParaRPr lang="en-US" sz="1500" dirty="0"/>
           </a:p>
@@ -15051,7 +15051,7 @@
                   <a:schemeClr val="tx1"/>
                 </a:solidFill>
               </a:rPr>
-              <a:t>82–89% of model time is reading the prompt: a CPU and memory-bandwidth cost that moves with the server</a:t>
+              <a:t>82–89% of the model's time goes on reading the ticket, so speed depends mostly on the server's processor and memory</a:t>
             </a:r>
             <a:endParaRPr lang="en-US" sz="1200" dirty="0"/>
           </a:p>
@@ -15069,7 +15069,7 @@
                   <a:schemeClr val="tx1"/>
                 </a:solidFill>
               </a:rPr>
-              <a:t>Capacity ≈ 60 ÷ mean model time: 3.1 s here, about 19 tickets/min for 7B</a:t>
+              <a:t>Capacity ≈ 60 s ÷ time per ticket: 3.1 s here, so about 19 tickets a minute for the large model</a:t>
             </a:r>
             <a:endParaRPr lang="en-US" sz="1200" dirty="0"/>
           </a:p>
@@ -15087,7 +15087,7 @@
                   <a:schemeClr val="tx1"/>
                 </a:solidFill>
               </a:rPr>
-              <a:t>Estimate: a server ~3× slower per ticket still keeps peak p95 &lt; 30 s. Re-measure one 7B ticket on the client's CPU first</a:t>
+              <a:t>Our estimate: a server up to 3× slower would still meet the 30 s target. Time one ticket on the bank's server first</a:t>
             </a:r>
             <a:endParaRPr lang="en-US" sz="1200" dirty="0"/>
           </a:p>
@@ -15126,7 +15126,7 @@
                 <a:ea typeface="Cambria" pitchFamily="34" charset="-122"/>
                 <a:cs typeface="Cambria" pitchFamily="34" charset="-120"/>
               </a:rPr>
-              <a:t>What could make our numbers unrepresentative</a:t>
+              <a:t>What could make our numbers misleading</a:t>
             </a:r>
             <a:endParaRPr lang="en-US" sz="1500" dirty="0"/>
           </a:p>
@@ -15166,7 +15166,7 @@
                   <a:schemeClr val="tx1"/>
                 </a:solidFill>
               </a:rPr>
-              <a:t>Apple Silicon (ARM, unified memory) ≠ x86 DDR servers; laptop thermals; power state not logged for official runs</a:t>
+              <a:t>A laptop chip is not a typical bank server chip; laptops slow down when hot; power source was not recorded</a:t>
             </a:r>
             <a:endParaRPr lang="en-US" sz="1200" dirty="0"/>
           </a:p>
@@ -15184,7 +15184,7 @@
                   <a:schemeClr val="tx1"/>
                 </a:solidFill>
               </a:rPr>
-              <a:t>Wi-Fi: search takes ≤ 7 ms in the service (p95) but 0.2–0.5 s at JMeter, so the network dominates it</a:t>
+              <a:t>Wi-Fi: a search takes under 7 ms inside the system but 0.2–0.5 s as JMeter sees it, so most of that is network</a:t>
             </a:r>
             <a:endParaRPr lang="en-US" sz="1200" dirty="0"/>
           </a:p>
@@ -15202,7 +15202,7 @@
                   <a:schemeClr val="tx1"/>
                 </a:solidFill>
               </a:rPr>
-              <a:t>10-min runs carry 14–35 POSTs: at ≤ 17 samples p99 equals the maximum</a:t>
+              <a:t>Each 10-min run has only 14–35 tickets, so the slowest-1% figure (p99) is just the slowest ticket</a:t>
             </a:r>
             <a:endParaRPr lang="en-US" sz="1200" dirty="0"/>
           </a:p>
@@ -15310,7 +15310,7 @@
                   <a:schemeClr val="tx2"/>
                 </a:solidFill>
               </a:rPr>
-              <a:t>Every run follows the same reset, load, reconcile loop</a:t>
+              <a:t>Every test run follows the same six steps</a:t>
             </a:r>
             <a:endParaRPr lang="en-US" sz="3000" dirty="0"/>
           </a:p>
@@ -15460,7 +15460,7 @@
                   <a:schemeClr val="tx1"/>
                 </a:solidFill>
               </a:rPr>
-              <a:t>Restart Ollama, delete the DB volume, check /health tag and digest</a:t>
+              <a:t>Restart the model server, empty the database, check the right model is loaded</a:t>
             </a:r>
             <a:endParaRPr lang="en-US" sz="1100" dirty="0"/>
           </a:p>
@@ -15634,7 +15634,7 @@
                   <a:schemeClr val="tx1"/>
                 </a:solidFill>
               </a:rPr>
-              <a:t>One invented ticket loads the model; recreate the DB empty</a:t>
+              <a:t>Send one made-up ticket to load the model, then empty the database again</a:t>
             </a:r>
             <a:endParaRPr lang="en-US" sz="1100" dirty="0"/>
           </a:p>
@@ -15808,7 +15808,7 @@
                   <a:schemeClr val="tx1"/>
                 </a:solidFill>
               </a:rPr>
-              <a:t>docker stats every 5 s into _stats.csv</a:t>
+              <a:t>Record processor and memory use every 5 s</a:t>
             </a:r>
             <a:endParaRPr lang="en-US" sz="1100" dirty="0"/>
           </a:p>
@@ -15982,7 +15982,7 @@
                   <a:schemeClr val="bg1"/>
                 </a:solidFill>
               </a:rPr>
-              <a:t>JMeter non-GUI on the separate Mac</a:t>
+              <a:t>JMeter sends traffic from the separate Mac</a:t>
             </a:r>
             <a:endParaRPr lang="en-US" sz="1100" dirty="0"/>
           </a:p>
@@ -16156,7 +16156,7 @@
                   <a:schemeClr val="tx1"/>
                 </a:solidFill>
               </a:rPr>
-              <a:t>Commit .jtl, JMeter log, service log, stats</a:t>
+              <a:t>Save JMeter results, service log and resource log</a:t>
             </a:r>
             <a:endParaRPr lang="en-US" sz="1100" dirty="0"/>
           </a:p>
@@ -16330,7 +16330,7 @@
                   <a:schemeClr val="tx1"/>
                 </a:solidFill>
               </a:rPr>
-              <a:t>Match every request ID; no unknown requests</a:t>
+              <a:t>Check every request appears in both logs, and nothing else does</a:t>
             </a:r>
             <a:endParaRPr lang="en-US" sz="1100" dirty="0"/>
           </a:p>
@@ -16436,7 +16436,7 @@
                   <a:schemeClr val="tx1"/>
                 </a:solidFill>
               </a:rPr>
-              <a:t>Open Model Thread Group: random (Poisson) arrivals at a fixed rate, so a slow server cannot slow the arrivals</a:t>
+              <a:t>Tickets arrive at random moments at a set average rate, even if the system falls behind, so any backlog shows</a:t>
             </a:r>
             <a:endParaRPr lang="en-US" sz="1200" dirty="0"/>
           </a:p>
@@ -16454,7 +16454,7 @@
                   <a:schemeClr val="tx1"/>
                 </a:solidFill>
               </a:rPr>
-              <a:t>3 models × {1.45/2.9, 1.73/3.5, 3.5/7} tickets/searches per min × 3 runs</a:t>
+              <a:t>3 models × 3 traffic levels (normal, busiest, double) × 3 runs each</a:t>
             </a:r>
             <a:endParaRPr lang="en-US" sz="1200" dirty="0"/>
           </a:p>
@@ -16472,7 +16472,7 @@
                   <a:schemeClr val="tx1"/>
                 </a:solidFill>
               </a:rPr>
-              <a:t>10 min arrivals + 5 min drain; timeout 600 s</a:t>
+              <a:t>10 min of traffic, then 5 min for the last tickets to finish; over 10 min counts as failed</a:t>
             </a:r>
             <a:endParaRPr lang="en-US" sz="1200" dirty="0"/>
           </a:p>
@@ -16490,7 +16490,7 @@
                   <a:schemeClr val="tx1"/>
                 </a:solidFill>
               </a:rPr>
-              <a:t>Tickets from rows 3200–3999 (golden rows excluded), same order each run; X-Request-ID on every request</a:t>
+              <a:t>Tickets from rows 3200–3999, never the hand-checked ones; each request tagged with an ID</a:t>
             </a:r>
             <a:endParaRPr lang="en-US" sz="1200" dirty="0"/>
           </a:p>
@@ -16596,7 +16596,7 @@
                   <a:schemeClr val="tx1"/>
                 </a:solidFill>
               </a:rPr>
-              <a:t>All 195 golden tickets sent once each through POST /tickets, one at a time</a:t>
+              <a:t>Each of the 195 hand-checked tickets sent once, one at a time, to each model</a:t>
             </a:r>
             <a:endParaRPr lang="en-US" sz="1200" dirty="0"/>
           </a:p>
@@ -16614,7 +16614,7 @@
                   <a:schemeClr val="tx1"/>
                 </a:solidFill>
               </a:rPr>
-              <a:t>Scored against golden labels: overall, per-category recall and precision, confusion matrix</a:t>
+              <a:t>Compared with our labels: overall, per category, and which categories get mixed up</a:t>
             </a:r>
             <a:endParaRPr lang="en-US" sz="1200" dirty="0"/>
           </a:p>
@@ -16632,7 +16632,7 @@
                   <a:schemeClr val="tx1"/>
                 </a:solidFill>
               </a:rPr>
-              <a:t>Run 8 Oct, after the freeze; no load test running at the same time</a:t>
+              <a:t>Run on 8 Oct, after the labels were locked; no other test running</a:t>
             </a:r>
             <a:endParaRPr lang="en-US" sz="1200" dirty="0"/>
           </a:p>
@@ -16698,7 +16698,7 @@
                 <a:ea typeface="Cambria" pitchFamily="34" charset="-122"/>
                 <a:cs typeface="Cambria" pitchFamily="34" charset="-120"/>
               </a:rPr>
-              <a:t>Stress test: qwen2.5:7b</a:t>
+              <a:t>Stress test: large model</a:t>
             </a:r>
             <a:endParaRPr lang="en-US" sz="1500" dirty="0"/>
           </a:p>
@@ -16738,7 +16738,7 @@
                   <a:schemeClr val="tx1"/>
                 </a:solidFill>
               </a:rPr>
-              <a:t>Ramp 3.5 → 12 tickets/min over 30 min (+ 7 searches/min, 10 min drain)</a:t>
+              <a:t>Traffic rises steadily from 3.5 to 12 tickets/min over 30 min, plus 7 searches/min</a:t>
             </a:r>
             <a:endParaRPr lang="en-US" sz="1200" dirty="0"/>
           </a:p>
@@ -16756,7 +16756,7 @@
                   <a:schemeClr val="tx1"/>
                 </a:solidFill>
               </a:rPr>
-              <a:t>Confirm with 15-min constant runs at 7.2 and 9.6/min</a:t>
+              <a:t>Then 15 min at a steady 7.2 and 9.6 tickets/min to confirm</a:t>
             </a:r>
             <a:endParaRPr lang="en-US" sz="1200" dirty="0"/>
           </a:p>
@@ -16774,7 +16774,7 @@
                   <a:schemeClr val="tx1"/>
                 </a:solidFill>
               </a:rPr>
-              <a:t>Limit = throughput stops tracking arrivals and latency grows through the run</a:t>
+              <a:t>The limit is where tickets arrive faster than they are sorted and delays keep growing</a:t>
             </a:r>
             <a:endParaRPr lang="en-US" sz="1200" dirty="0"/>
           </a:p>
@@ -16792,7 +16792,7 @@
                   <a:schemeClr val="tx1"/>
                 </a:solidFill>
               </a:rPr>
-              <a:t>Diagnose: Ollama queue wait = total − prompt − generation time</a:t>
+              <a:t>Each ticket's time is split into waiting in line vs being processed</a:t>
             </a:r>
             <a:endParaRPr lang="en-US" sz="1200" dirty="0"/>
           </a:p>
@@ -16900,7 +16900,7 @@
                   <a:schemeClr val="tx2"/>
                 </a:solidFill>
               </a:rPr>
-              <a:t>All models meet R1–R3 easily; Ollama is the bottleneck</a:t>
+              <a:t>All three models keep up easily; the AI model is the slow part</a:t>
             </a:r>
             <a:endParaRPr lang="en-US" sz="3000" dirty="0"/>
           </a:p>
@@ -16938,7 +16938,7 @@
                 <a:gridCol w="548640"/>
                 <a:gridCol w="1097280"/>
               </a:tblGrid>
-              <a:tr h="338328">
+              <a:tr h="566928">
                 <a:tc>
                   <a:txBody>
                     <a:bodyPr/>
@@ -17014,7 +17014,7 @@
                             <a:schemeClr val="bg1"/>
                           </a:solidFill>
                         </a:rPr>
-                        <a:t>Load /min</a:t>
+                        <a:t>Tickets + searches /min</a:t>
                       </a:r>
                       <a:endParaRPr lang="en-US" sz="1100" dirty="0"/>
                     </a:p>
@@ -17075,7 +17075,7 @@
                             <a:schemeClr val="bg1"/>
                           </a:solidFill>
                         </a:rPr>
-                        <a:t>p50 s</a:t>
+                        <a:t>Typical (p50) s</a:t>
                       </a:r>
                       <a:endParaRPr lang="en-US" sz="1100" dirty="0"/>
                     </a:p>
@@ -17136,7 +17136,7 @@
                             <a:schemeClr val="bg1"/>
                           </a:solidFill>
                         </a:rPr>
-                        <a:t>p95 s</a:t>
+                        <a:t>95% within (p95) s</a:t>
                       </a:r>
                       <a:endParaRPr lang="en-US" sz="1100" dirty="0"/>
                     </a:p>
@@ -17197,7 +17197,7 @@
                             <a:schemeClr val="bg1"/>
                           </a:solidFill>
                         </a:rPr>
-                        <a:t>p99 s</a:t>
+                        <a:t>99% (p99) s</a:t>
                       </a:r>
                       <a:endParaRPr lang="en-US" sz="1100" dirty="0"/>
                     </a:p>
@@ -17258,7 +17258,7 @@
                             <a:schemeClr val="bg1"/>
                           </a:solidFill>
                         </a:rPr>
-                        <a:t>Thru /min</a:t>
+                        <a:t>Done /min</a:t>
                       </a:r>
                       <a:endParaRPr lang="en-US" sz="1100" dirty="0"/>
                     </a:p>
@@ -17319,7 +17319,7 @@
                             <a:schemeClr val="bg1"/>
                           </a:solidFill>
                         </a:rPr>
-                        <a:t>Err</a:t>
+                        <a:t>Failed</a:t>
                       </a:r>
                       <a:endParaRPr lang="en-US" sz="1100" dirty="0"/>
                     </a:p>
@@ -17380,7 +17380,7 @@
                             <a:schemeClr val="bg1"/>
                           </a:solidFill>
                         </a:rPr>
-                        <a:t>Search p95 s</a:t>
+                        <a:t>Search 95% within s</a:t>
                       </a:r>
                       <a:endParaRPr lang="en-US" sz="1100" dirty="0"/>
                     </a:p>
@@ -17428,7 +17428,7 @@
                   </a:tcPr>
                 </a:tc>
               </a:tr>
-              <a:tr h="338328">
+              <a:tr h="310896">
                 <a:tc rowSpan="3">
                   <a:txBody>
                     <a:bodyPr/>
@@ -17894,7 +17894,7 @@
                   </a:tcPr>
                 </a:tc>
               </a:tr>
-              <a:tr h="338328">
+              <a:tr h="310896">
                 <a:tc vMerge="1">
                   <a:tcPr/>
                 </a:tc>
@@ -18326,7 +18326,7 @@
                   </a:tcPr>
                 </a:tc>
               </a:tr>
-              <a:tr h="338328">
+              <a:tr h="310896">
                 <a:tc vMerge="1">
                   <a:tcPr/>
                 </a:tc>
@@ -18737,7 +18737,7 @@
                   </a:tcPr>
                 </a:tc>
               </a:tr>
-              <a:tr h="338328">
+              <a:tr h="310896">
                 <a:tc rowSpan="3">
                   <a:txBody>
                     <a:bodyPr/>
@@ -19203,7 +19203,7 @@
                   </a:tcPr>
                 </a:tc>
               </a:tr>
-              <a:tr h="338328">
+              <a:tr h="310896">
                 <a:tc vMerge="1">
                   <a:tcPr/>
                 </a:tc>
@@ -19635,7 +19635,7 @@
                   </a:tcPr>
                 </a:tc>
               </a:tr>
-              <a:tr h="338328">
+              <a:tr h="310896">
                 <a:tc vMerge="1">
                   <a:tcPr/>
                 </a:tc>
@@ -20046,7 +20046,7 @@
                   </a:tcPr>
                 </a:tc>
               </a:tr>
-              <a:tr h="338328">
+              <a:tr h="310896">
                 <a:tc rowSpan="3">
                   <a:txBody>
                     <a:bodyPr/>
@@ -20512,7 +20512,7 @@
                   </a:tcPr>
                 </a:tc>
               </a:tr>
-              <a:tr h="338328">
+              <a:tr h="310896">
                 <a:tc vMerge="1">
                   <a:tcPr/>
                 </a:tc>
@@ -20944,7 +20944,7 @@
                   </a:tcPr>
                 </a:tc>
               </a:tr>
-              <a:tr h="338328">
+              <a:tr h="310896">
                 <a:tc vMerge="1">
                   <a:tcPr/>
                 </a:tc>
@@ -21389,7 +21389,7 @@
                   <a:schemeClr val="accent5"/>
                 </a:solidFill>
               </a:rPr>
-              <a:t>POST /tickets latency; mean (min–max) of 3 runs. Shaded = peak, where R1–R3 apply. p99 range in repo summary.</a:t>
+              <a:t>Seconds to sort a ticket: average of 3 runs (lowest–highest). Shaded = busiest hour, where targets R1–R3 apply.</a:t>
             </a:r>
             <a:endParaRPr lang="en-US" sz="1000" dirty="0"/>
           </a:p>
@@ -21541,7 +21541,7 @@
                   <a:schemeClr val="tx1"/>
                 </a:solidFill>
               </a:rPr>
-              <a:t>peak p95 ≤ 30 s: worst 6.06 s (7B)</a:t>
+              <a:t>95% of tickets sorted within 6.1 s at worst (target 30 s)</a:t>
             </a:r>
             <a:endParaRPr lang="en-US" sz="1100" dirty="0"/>
           </a:p>
@@ -21693,7 +21693,7 @@
                   <a:schemeClr val="tx1"/>
                 </a:solidFill>
               </a:rPr>
-              <a:t>search p95 ≤ 1 s: worst 0.46 s</a:t>
+              <a:t>95% of searches within 0.46 s at worst (target 1 s)</a:t>
             </a:r>
             <a:endParaRPr lang="en-US" sz="1100" dirty="0"/>
           </a:p>
@@ -21845,7 +21845,7 @@
                   <a:schemeClr val="tx1"/>
                 </a:solidFill>
               </a:rPr>
-              <a:t>0 errors in 27 runs; throughput tracks arrivals</a:t>
+              <a:t>No failures in 27 runs; tickets sorted as fast as they arrived</a:t>
             </a:r>
             <a:endParaRPr lang="en-US" sz="1100" dirty="0"/>
           </a:p>
@@ -21903,7 +21903,7 @@
                   <a:srgbClr val="9BC1BC"/>
                 </a:solidFill>
               </a:rPr>
-              <a:t>STRESS TEST · qwen2.5:7b</a:t>
+              <a:t>STRESS TEST · large model</a:t>
             </a:r>
             <a:endParaRPr lang="en-US" sz="1100" dirty="0"/>
           </a:p>
@@ -21939,7 +21939,7 @@
                   <a:schemeClr val="bg1"/>
                 </a:solidFill>
               </a:rPr>
-              <a:t>Ramp 3.5 → 12</a:t>
+              <a:t>Rising 3.5 → 12 /min</a:t>
             </a:r>
             <a:endParaRPr lang="en-US" sz="1200" dirty="0"/>
           </a:p>
@@ -21975,7 +21975,7 @@
                   <a:srgbClr val="CADDDA"/>
                 </a:solidFill>
               </a:rPr>
-              <a:t>232 POSTs · p95 10.2 s · 0 errors</a:t>
+              <a:t>232 tickets · 95% within 10.2 s · 0 failed</a:t>
             </a:r>
             <a:endParaRPr lang="en-US" sz="1100" dirty="0"/>
           </a:p>
@@ -22011,7 +22011,7 @@
                   <a:schemeClr val="bg1"/>
                 </a:solidFill>
               </a:rPr>
-              <a:t>7.2 /min, 15 min</a:t>
+              <a:t>Steady 7.2 /min</a:t>
             </a:r>
             <a:endParaRPr lang="en-US" sz="1200" dirty="0"/>
           </a:p>
@@ -22047,7 +22047,7 @@
                   <a:srgbClr val="CADDDA"/>
                 </a:solidFill>
               </a:rPr>
-              <a:t>108 POSTs · p95 8.7 s · 0 errors</a:t>
+              <a:t>108 tickets · 95% within 8.7 s · 0 failed</a:t>
             </a:r>
             <a:endParaRPr lang="en-US" sz="1100" dirty="0"/>
           </a:p>
@@ -22083,7 +22083,7 @@
                   <a:schemeClr val="bg1"/>
                 </a:solidFill>
               </a:rPr>
-              <a:t>9.6 /min, 15 min</a:t>
+              <a:t>Steady 9.6 /min</a:t>
             </a:r>
             <a:endParaRPr lang="en-US" sz="1200" dirty="0"/>
           </a:p>
@@ -22119,7 +22119,7 @@
                   <a:srgbClr val="CADDDA"/>
                 </a:solidFill>
               </a:rPr>
-              <a:t>144 POSTs · p95 17.3 s · 0 errors</a:t>
+              <a:t>144 tickets · 95% within 17.3 s · 0 failed</a:t>
             </a:r>
             <a:endParaRPr lang="en-US" sz="1100" dirty="0"/>
           </a:p>
@@ -22194,7 +22194,7 @@
                   <a:schemeClr val="bg1"/>
                 </a:solidFill>
               </a:rPr>
-              <a:t>Sustained 9.6 /min with no latency growth: 5.5× peak. Estimated limit ≈ 19 /min (60 ÷ 3.1 s), not yet confirmed.</a:t>
+              <a:t>It kept up at 9.6 /min, 5.5× the busiest hour, without delays growing. We estimate it tops out near 19 /min (60 s ÷ 3.1 s per ticket); not yet confirmed.</a:t>
             </a:r>
             <a:endParaRPr lang="en-US" sz="1100" dirty="0"/>
           </a:p>
@@ -22233,7 +22233,7 @@
                 <a:ea typeface="Cambria" pitchFamily="34" charset="-122"/>
                 <a:cs typeface="Cambria" pitchFamily="34" charset="-120"/>
               </a:rPr>
-              <a:t>Bottleneck: Ollama</a:t>
+              <a:t>Slow part: the AI model</a:t>
             </a:r>
             <a:endParaRPr lang="en-US" sz="1400" dirty="0"/>
           </a:p>
@@ -22269,7 +22269,7 @@
                   <a:schemeClr val="bg1"/>
                 </a:solidFill>
               </a:rPr>
-              <a:t>Wait in our service &lt; 0.1 s; at 9.6 /min the wait inside Ollama's FIFO reaches p95 14.6 s. Ollama CPU p99 1,040% vs triage ≤ 6.8%.</a:t>
+              <a:t>Tickets wait under 0.1 s in our service, but up to 14.6 s (95%) in the model's own queue at 9.6 /min. The model keeps ~10 cores busy; our service under 7% of one.</a:t>
             </a:r>
             <a:endParaRPr lang="en-US" sz="1100" dirty="0"/>
           </a:p>

</xml_diff>

<commit_message>
IEEE references and citations; drop untested fourth model from slides
Slide 12 now lists 12 IEEE references numbered by first citation, adding
Ollama, JMeter, the Qwen2.5 report and the Apache 2.0 and Llama 3.2
licences. Citation markers on slides 2-5 and 11 renumbered to match.
</commit_message>
<xml_diff>
--- a/slides/Group03.pptx
+++ b/slides/Group03.pptx
@@ -118,31 +118,31 @@
   <p:extLst>
     <p:ext uri="{521415D9-36F7-43E2-AB2F-B90AF26B5E84}">
       <p14:sectionLst xmlns:p14="http://schemas.microsoft.com/office/powerpoint/2010/main">
-        <p14:section name="Introduction" id="{40be89e4-fb38-bdb4-915a-131348b6baa1}">
+        <p14:section name="Introduction" id="{3c780a86-3036-583a-49d9-5fb0cf74fc23}">
           <p14:sldIdLst>
             <p14:sldId id="256"/>
           </p14:sldIdLst>
         </p14:section>
-        <p14:section name="System and workload" id="{63c07d94-5f8d-2bdf-bdcd-ceb515c73309}">
+        <p14:section name="System and workload" id="{bd3493fb-ffd0-c25b-27e7-a53bbb10ec98}">
           <p14:sldIdLst>
             <p14:sldId id="257"/>
             <p14:sldId id="258"/>
           </p14:sldIdLst>
         </p14:section>
-        <p14:section name="Requirements and candidates" id="{0027618d-8779-e849-4297-c0dbdb973ad6}">
+        <p14:section name="Requirements and candidates" id="{a7649814-2570-e00c-bcfa-fa22d25b7fde}">
           <p14:sldIdLst>
             <p14:sldId id="259"/>
             <p14:sldId id="260"/>
           </p14:sldIdLst>
         </p14:section>
-        <p14:section name="Golden set and testing" id="{85547ecd-d3a9-7cdf-d0a4-14bf98472614}">
+        <p14:section name="Golden set and testing" id="{6acf025e-6ff1-957c-36d7-a05b6429daa6}">
           <p14:sldIdLst>
             <p14:sldId id="261"/>
             <p14:sldId id="262"/>
             <p14:sldId id="263"/>
           </p14:sldIdLst>
         </p14:section>
-        <p14:section name="Results and recommendation" id="{6a2fac3c-fa64-f15c-eef4-946fe0026c08}">
+        <p14:section name="Results and recommendation" id="{6a100870-ea1f-5006-e6a0-6081ac680af7}">
           <p14:sldIdLst>
             <p14:sldId id="264"/>
             <p14:sldId id="265"/>
@@ -185,7 +185,7 @@
                 </a:solidFill>
                 <a:latin typeface="+mn-lt"/>
               </a:rPr>
-              <a:t>Ticket length in characters (our 1,000)</a:t>
+              <a:t>Ticket length in characters (our 1,000) [8]</a:t>
             </a:r>
           </a:p>
         </c:rich>
@@ -1805,7 +1805,7 @@
           <a:p>
             <a:r>
               <a:rPr lang="en-US" dirty="0"/>
-              <a:t>Licences: Qwen2.5 0.5B and 7B are Apache 2.0; Llama 3.2 Community License requires 'Built with Llama' attribution and a copy of the licence on redistribution; Ollama is MIT; Apache JMeter is Apache 2.0.</a:t>
+              <a:t>IEEE style, numbered in order of first citation in the deck. Licences: Qwen2.5 0.5B and 7B are Apache 2.0; the Llama 3.2 Community License requires 'Built with Llama' attribution and a copy of the licence on redistribution; Ollama is MIT; Apache JMeter is Apache 2.0.</a:t>
             </a:r>
             <a:endParaRPr lang="en-US" dirty="0"/>
           </a:p>
@@ -2157,7 +2157,7 @@
           <a:p>
             <a:r>
               <a:rPr lang="en-US" dirty="0"/>
-              <a:t>Source: models/models.lock.json, docs/models.md. qwen2.5:3b was in the four-model lock at tag prediction-freeze.</a:t>
+              <a:t>Source: models/models.lock.json, docs/models.md.</a:t>
             </a:r>
             <a:endParaRPr lang="en-US" dirty="0"/>
           </a:p>
@@ -6463,7 +6463,7 @@
                   <a:schemeClr val="bg1"/>
                 </a:solidFill>
               </a:rPr>
-              <a:t>Its licence (Apache 2.0) allows commercial use; runs on one standard server</a:t>
+              <a:t>Its licence (Apache 2.0 [11]) allows commercial use; runs on one standard server</a:t>
             </a:r>
             <a:endParaRPr lang="en-US" sz="1200" dirty="0"/>
           </a:p>
@@ -6698,46 +6698,7 @@
         <p:spPr>
           <a:xfrm>
             <a:off x="548640" y="1280160"/>
-            <a:ext cx="6675120" cy="320040"/>
-          </a:xfrm>
-          <a:prstGeom prst="rect">
-            <a:avLst/>
-          </a:prstGeom>
-          <a:noFill/>
-          <a:ln/>
-        </p:spPr>
-        <p:txBody>
-          <a:bodyPr wrap="square" lIns="0" tIns="0" rIns="0" bIns="0" rtlCol="0" anchor="t"/>
-          <a:lstStyle/>
-          <a:p>
-            <a:pPr indent="0" marL="0">
-              <a:buNone/>
-            </a:pPr>
-            <a:r>
-              <a:rPr lang="en-US" sz="1600" b="1" dirty="0">
-                <a:solidFill>
-                  <a:schemeClr val="tx2"/>
-                </a:solidFill>
-                <a:latin typeface="Cambria" pitchFamily="34" charset="0"/>
-                <a:ea typeface="Cambria" pitchFamily="34" charset="-122"/>
-                <a:cs typeface="Cambria" pitchFamily="34" charset="-120"/>
-              </a:rPr>
-              <a:t>References</a:t>
-            </a:r>
-            <a:endParaRPr lang="en-US" sz="1600" dirty="0"/>
-          </a:p>
-        </p:txBody>
-      </p:sp>
-      <p:sp>
-        <p:nvSpPr>
-          <p:cNvPr id="5" name="Text 2"/>
-          <p:cNvSpPr txBox="1"/>
-          <p:nvPr/>
-        </p:nvSpPr>
-        <p:spPr>
-          <a:xfrm>
-            <a:off x="548640" y="1691640"/>
-            <a:ext cx="6675120" cy="4572000"/>
+            <a:ext cx="5364328" cy="4160520"/>
           </a:xfrm>
           <a:prstGeom prst="rect">
             <a:avLst/>
@@ -6761,7 +6722,7 @@
                   <a:schemeClr val="tx1"/>
                 </a:solidFill>
               </a:rPr>
-              <a:t>[1] Lloyds Banking Group (2026). Complaints publication report: Bank of Scotland plc, 1 July – 31 December 2025. lloydsbankinggroup.com</a:t>
+              <a:t>[1] Ollama, "Ollama," ver. 0.35.1, MIT License. [Online]. Available: https://github.com/ollama/ollama. Accessed: Oct. 9, 2026.</a:t>
             </a:r>
             <a:endParaRPr lang="en-US" sz="1100" dirty="0"/>
           </a:p>
@@ -6778,7 +6739,7 @@
                   <a:schemeClr val="tx1"/>
                 </a:solidFill>
               </a:rPr>
-              <a:t>[2] Financial Conduct Authority (2026). Aggregate complaints data: 2025 H2. fca.org.uk/data/complaints-data/aggregate-complaints-data-2025-h2</a:t>
+              <a:t>[2] The Apache Software Foundation, "Apache JMeter," ver. 5.6.3. [Online]. Available: https://jmeter.apache.org/. Accessed: Oct. 9, 2026.</a:t>
             </a:r>
             <a:endParaRPr lang="en-US" sz="1100" dirty="0"/>
           </a:p>
@@ -6795,7 +6756,7 @@
                   <a:schemeClr val="tx1"/>
                 </a:solidFill>
               </a:rPr>
-              <a:t>[3] Brown, L. et al. (2005). Statistical analysis of a telephone call center: a queueing-science perspective. JASA, 100(469), 36–50.</a:t>
+              <a:t>[3] Lloyds Banking Group, "Complaints publication report: Bank of Scotland plc, 1 July to 31 December 2025," 2026. [Online]. Available: https://www.lloydsbankinggroup.com/assets/pdfs/who-we-are/customer-complaints/2025/h2-2025/bank-of-scotland-plc.pdf. Accessed: Oct. 9, 2026.</a:t>
             </a:r>
             <a:endParaRPr lang="en-US" sz="1100" dirty="0"/>
           </a:p>
@@ -6812,7 +6773,7 @@
                   <a:schemeClr val="tx1"/>
                 </a:solidFill>
               </a:rPr>
-              <a:t>[4] Soon. How many agents do you need for 500 calls a day? soon.works/staffing/call-center/500-calls-per-day</a:t>
+              <a:t>[4] Financial Conduct Authority, "Aggregate complaints data: 2025 H2," 2026. [Online]. Available: https://www.fca.org.uk/data/complaints-data/aggregate-complaints-data-2025-h2. Accessed: Oct. 9, 2026.</a:t>
             </a:r>
             <a:endParaRPr lang="en-US" sz="1100" dirty="0"/>
           </a:p>
@@ -6829,7 +6790,7 @@
                   <a:schemeClr val="tx1"/>
                 </a:solidFill>
               </a:rPr>
-              <a:t>[5] Financial Conduct Authority. FCA Handbook Glossary: complaint. handbook.fca.org.uk/glossary/G197</a:t>
+              <a:t>[5] L. Brown, N. Gans, A. Mandelbaum, A. Sakov, H. Shen, S. Zeltyn, and L. Zhao, "Statistical analysis of a telephone call center: A queueing-science perspective," J. Amer. Statist. Assoc., vol. 100, no. 469, pp. 36–50, 2005, doi: 10.2307/27590517.</a:t>
             </a:r>
             <a:endParaRPr lang="en-US" sz="1100" dirty="0"/>
           </a:p>
@@ -6846,10 +6807,32 @@
                   <a:schemeClr val="tx1"/>
                 </a:solidFill>
               </a:rPr>
-              <a:t>[6] Consumer Financial Protection Bureau. Consumer Complaint Database. consumerfinance.gov/data-research/consumer-complaints (course extract, rows 3000–3999)</a:t>
+              <a:t>[6] Soon, "How many agents do you need for 500 calls a day?" [Online]. Available: https://soon.works/staffing/call-center/500-calls-per-day. Accessed: Oct. 9, 2026.</a:t>
             </a:r>
             <a:endParaRPr lang="en-US" sz="1100" dirty="0"/>
           </a:p>
+        </p:txBody>
+      </p:sp>
+      <p:sp>
+        <p:nvSpPr>
+          <p:cNvPr id="5" name="Text 2"/>
+          <p:cNvSpPr txBox="1"/>
+          <p:nvPr/>
+        </p:nvSpPr>
+        <p:spPr>
+          <a:xfrm>
+            <a:off x="6278728" y="1280160"/>
+            <a:ext cx="5364328" cy="4160520"/>
+          </a:xfrm>
+          <a:prstGeom prst="rect">
+            <a:avLst/>
+          </a:prstGeom>
+          <a:noFill/>
+          <a:ln/>
+        </p:spPr>
+        <p:txBody>
+          <a:bodyPr wrap="square" lIns="0" tIns="0" rIns="0" bIns="0" rtlCol="0" anchor="t"/>
+          <a:lstStyle/>
           <a:p>
             <a:pPr indent="0" marL="0">
               <a:spcAft>
@@ -6863,7 +6846,92 @@
                   <a:schemeClr val="tx1"/>
                 </a:solidFill>
               </a:rPr>
-              <a:t>[7] Nielsen, J. (1993). Response times: the 3 important limits. Nielsen Norman Group. nngroup.com/articles/response-times-3-important-limits</a:t>
+              <a:t>[7] Financial Conduct Authority, "Complaint," FCA Handbook Glossary. [Online]. Available: https://www.handbook.fca.org.uk/handbook/glossary/G197.html. Accessed: Oct. 9, 2026.</a:t>
+            </a:r>
+            <a:endParaRPr lang="en-US" sz="1100" dirty="0"/>
+          </a:p>
+          <a:p>
+            <a:pPr indent="0" marL="0">
+              <a:spcAft>
+                <a:spcPts val="600"/>
+              </a:spcAft>
+              <a:buNone/>
+            </a:pPr>
+            <a:r>
+              <a:rPr lang="en-US" sz="1100" dirty="0">
+                <a:solidFill>
+                  <a:schemeClr val="tx1"/>
+                </a:solidFill>
+              </a:rPr>
+              <a:t>[8] Consumer Financial Protection Bureau, "Consumer Complaint Database." [Online]. Available: https://www.consumerfinance.gov/data-research/consumer-complaints/. Course extract (rows 3000–3999) provided by Singapore Institute of Technology for ICT3113 via xSiTe.</a:t>
+            </a:r>
+            <a:endParaRPr lang="en-US" sz="1100" dirty="0"/>
+          </a:p>
+          <a:p>
+            <a:pPr indent="0" marL="0">
+              <a:spcAft>
+                <a:spcPts val="600"/>
+              </a:spcAft>
+              <a:buNone/>
+            </a:pPr>
+            <a:r>
+              <a:rPr lang="en-US" sz="1100" dirty="0">
+                <a:solidFill>
+                  <a:schemeClr val="tx1"/>
+                </a:solidFill>
+              </a:rPr>
+              <a:t>[9] J. Nielsen, "Response times: The 3 important limits," Nielsen Norman Group, Jan. 1, 1993. [Online]. Available: https://www.nngroup.com/articles/response-times-3-important-limits/. Accessed: Oct. 9, 2026.</a:t>
+            </a:r>
+            <a:endParaRPr lang="en-US" sz="1100" dirty="0"/>
+          </a:p>
+          <a:p>
+            <a:pPr indent="0" marL="0">
+              <a:spcAft>
+                <a:spcPts val="600"/>
+              </a:spcAft>
+              <a:buNone/>
+            </a:pPr>
+            <a:r>
+              <a:rPr lang="en-US" sz="1100" dirty="0">
+                <a:solidFill>
+                  <a:schemeClr val="tx1"/>
+                </a:solidFill>
+              </a:rPr>
+              <a:t>[10] A. Yang et al., "Qwen2.5 technical report," 2024, arXiv:2412.15115.</a:t>
+            </a:r>
+            <a:endParaRPr lang="en-US" sz="1100" dirty="0"/>
+          </a:p>
+          <a:p>
+            <a:pPr indent="0" marL="0">
+              <a:spcAft>
+                <a:spcPts val="600"/>
+              </a:spcAft>
+              <a:buNone/>
+            </a:pPr>
+            <a:r>
+              <a:rPr lang="en-US" sz="1100" dirty="0">
+                <a:solidFill>
+                  <a:schemeClr val="tx1"/>
+                </a:solidFill>
+              </a:rPr>
+              <a:t>[11] The Apache Software Foundation, "Apache License, Version 2.0," Jan. 2004. [Online]. Available: https://www.apache.org/licenses/LICENSE-2.0. Accessed: Oct. 9, 2026.</a:t>
+            </a:r>
+            <a:endParaRPr lang="en-US" sz="1100" dirty="0"/>
+          </a:p>
+          <a:p>
+            <a:pPr indent="0" marL="0">
+              <a:spcAft>
+                <a:spcPts val="600"/>
+              </a:spcAft>
+              <a:buNone/>
+            </a:pPr>
+            <a:r>
+              <a:rPr lang="en-US" sz="1100" dirty="0">
+                <a:solidFill>
+                  <a:schemeClr val="tx1"/>
+                </a:solidFill>
+              </a:rPr>
+              <a:t>[12] Meta Platforms, "Llama 3.2 Community License Agreement," Sep. 25, 2024. [Online]. Available: https://www.llama.com/llama3_2/license/. Accessed: Oct. 9, 2026.</a:t>
             </a:r>
             <a:endParaRPr lang="en-US" sz="1100" dirty="0"/>
           </a:p>
@@ -6877,12 +6945,12 @@
         </p:nvSpPr>
         <p:spPr>
           <a:xfrm>
-            <a:off x="7589520" y="1280160"/>
-            <a:ext cx="4053535" cy="3017520"/>
+            <a:off x="548640" y="5532120"/>
+            <a:ext cx="11094415" cy="731520"/>
           </a:xfrm>
           <a:prstGeom prst="roundRect">
             <a:avLst>
-              <a:gd name="adj" fmla="val 2424"/>
+              <a:gd name="adj" fmla="val 10000"/>
             </a:avLst>
           </a:prstGeom>
           <a:solidFill>
@@ -6899,8 +6967,8 @@
         </p:nvSpPr>
         <p:spPr>
           <a:xfrm>
-            <a:off x="7818120" y="1389888"/>
-            <a:ext cx="3596335" cy="320040"/>
+            <a:off x="777240" y="5532120"/>
+            <a:ext cx="10637215" cy="731520"/>
           </a:xfrm>
           <a:prstGeom prst="rect">
             <a:avLst/>
@@ -6909,230 +6977,30 @@
           <a:ln/>
         </p:spPr>
         <p:txBody>
-          <a:bodyPr wrap="square" lIns="0" tIns="0" rIns="0" bIns="0" rtlCol="0" anchor="t"/>
+          <a:bodyPr wrap="square" lIns="0" tIns="0" rIns="0" bIns="0" rtlCol="0" anchor="ctr"/>
           <a:lstStyle/>
           <a:p>
             <a:pPr indent="0" marL="0">
               <a:buNone/>
             </a:pPr>
             <a:r>
-              <a:rPr lang="en-US" sz="1400" b="1" dirty="0">
+              <a:rPr lang="en-US" sz="1100" b="1" dirty="0">
                 <a:solidFill>
                   <a:schemeClr val="tx2"/>
                 </a:solidFill>
               </a:rPr>
-              <a:t>Software and model licences</a:t>
-            </a:r>
-            <a:endParaRPr lang="en-US" sz="1400" dirty="0"/>
-          </a:p>
-        </p:txBody>
-      </p:sp>
-      <p:sp>
-        <p:nvSpPr>
-          <p:cNvPr id="8" name="Text 5"/>
-          <p:cNvSpPr txBox="1"/>
-          <p:nvPr/>
-        </p:nvSpPr>
-        <p:spPr>
-          <a:xfrm>
-            <a:off x="7818120" y="1755648"/>
-            <a:ext cx="3596335" cy="2468880"/>
-          </a:xfrm>
-          <a:prstGeom prst="rect">
-            <a:avLst/>
-          </a:prstGeom>
-          <a:noFill/>
-          <a:ln/>
-        </p:spPr>
-        <p:txBody>
-          <a:bodyPr wrap="square" lIns="0" tIns="0" rIns="0" bIns="0" rtlCol="0" anchor="t"/>
-          <a:lstStyle/>
-          <a:p>
-            <a:pPr marL="342900" indent="-342900">
-              <a:spcAft>
-                <a:spcPts val="300"/>
-              </a:spcAft>
-              <a:buSzPct val="100000"/>
-              <a:buChar char="•"/>
-            </a:pPr>
-            <a:r>
-              <a:rPr lang="en-US" sz="1100" dirty="0">
-                <a:solidFill>
-                  <a:schemeClr val="tx1"/>
-                </a:solidFill>
-              </a:rPr>
-              <a:t>Ollama 0.35.1, MIT License. ollama.com</a:t>
-            </a:r>
-            <a:endParaRPr lang="en-US" sz="1100" dirty="0"/>
-          </a:p>
-          <a:p>
-            <a:pPr marL="342900" indent="-342900">
-              <a:spcAft>
-                <a:spcPts val="300"/>
-              </a:spcAft>
-              <a:buSzPct val="100000"/>
-              <a:buChar char="•"/>
-            </a:pPr>
-            <a:r>
-              <a:rPr lang="en-US" sz="1100" dirty="0">
-                <a:solidFill>
-                  <a:schemeClr val="tx1"/>
-                </a:solidFill>
-              </a:rPr>
-              <a:t>Qwen2.5 0.5B and 7B (Alibaba Cloud), Apache License 2.0</a:t>
-            </a:r>
-            <a:endParaRPr lang="en-US" sz="1100" dirty="0"/>
-          </a:p>
-          <a:p>
-            <a:pPr marL="342900" indent="-342900">
-              <a:spcAft>
-                <a:spcPts val="300"/>
-              </a:spcAft>
-              <a:buSzPct val="100000"/>
-              <a:buChar char="•"/>
-            </a:pPr>
-            <a:r>
-              <a:rPr lang="en-US" sz="1100" dirty="0">
-                <a:solidFill>
-                  <a:schemeClr val="tx1"/>
-                </a:solidFill>
-              </a:rPr>
-              <a:t>Llama 3.2 1B: Llama 3.2 Community License, Meta Platforms. Built with Llama</a:t>
-            </a:r>
-            <a:endParaRPr lang="en-US" sz="1100" dirty="0"/>
-          </a:p>
-          <a:p>
-            <a:pPr marL="342900" indent="-342900">
-              <a:spcAft>
-                <a:spcPts val="300"/>
-              </a:spcAft>
-              <a:buSzPct val="100000"/>
-              <a:buChar char="•"/>
-            </a:pPr>
-            <a:r>
-              <a:rPr lang="en-US" sz="1100" dirty="0">
-                <a:solidFill>
-                  <a:schemeClr val="tx1"/>
-                </a:solidFill>
-              </a:rPr>
-              <a:t>Apache JMeter 5.6.3, Apache License 2.0</a:t>
-            </a:r>
-            <a:endParaRPr lang="en-US" sz="1100" dirty="0"/>
-          </a:p>
-          <a:p>
-            <a:pPr marL="342900" indent="-342900">
-              <a:spcAft>
-                <a:spcPts val="300"/>
-              </a:spcAft>
-              <a:buSzPct val="100000"/>
-              <a:buChar char="•"/>
-            </a:pPr>
-            <a:r>
-              <a:rPr lang="en-US" sz="1100" dirty="0">
-                <a:solidFill>
-                  <a:schemeClr val="tx1"/>
-                </a:solidFill>
-              </a:rPr>
-              <a:t>FastAPI (MIT), SQLite (public domain), Docker</a:t>
-            </a:r>
-            <a:endParaRPr lang="en-US" sz="1100" dirty="0"/>
-          </a:p>
-        </p:txBody>
-      </p:sp>
-      <p:sp>
-        <p:nvSpPr>
-          <p:cNvPr id="9" name="Shape 6"/>
-          <p:cNvSpPr/>
-          <p:nvPr/>
-        </p:nvSpPr>
-        <p:spPr>
-          <a:xfrm>
-            <a:off x="7589520" y="4480560"/>
-            <a:ext cx="4053535" cy="1783080"/>
-          </a:xfrm>
-          <a:prstGeom prst="roundRect">
-            <a:avLst>
-              <a:gd name="adj" fmla="val 4103"/>
-            </a:avLst>
-          </a:prstGeom>
-          <a:solidFill>
-            <a:schemeClr val="bg1"/>
-          </a:solidFill>
-          <a:ln w="12700">
-            <a:solidFill>
-              <a:srgbClr val="D5DFDD"/>
-            </a:solidFill>
-            <a:prstDash val="solid"/>
-          </a:ln>
-        </p:spPr>
-      </p:sp>
-      <p:sp>
-        <p:nvSpPr>
-          <p:cNvPr id="10" name="Text 7"/>
-          <p:cNvSpPr txBox="1"/>
-          <p:nvPr/>
-        </p:nvSpPr>
-        <p:spPr>
-          <a:xfrm>
-            <a:off x="7818120" y="4572000"/>
-            <a:ext cx="3596335" cy="320040"/>
-          </a:xfrm>
-          <a:prstGeom prst="rect">
-            <a:avLst/>
-          </a:prstGeom>
-          <a:noFill/>
-          <a:ln/>
-        </p:spPr>
-        <p:txBody>
-          <a:bodyPr wrap="square" lIns="0" tIns="0" rIns="0" bIns="0" rtlCol="0" anchor="t"/>
-          <a:lstStyle/>
-          <a:p>
+              <a:t>Acknowledgements.  </a:t>
+            </a:r>
             <a:pPr indent="0" marL="0">
               <a:buNone/>
             </a:pPr>
             <a:r>
-              <a:rPr lang="en-US" sz="1400" b="1" dirty="0">
-                <a:solidFill>
-                  <a:schemeClr val="tx2"/>
-                </a:solidFill>
-              </a:rPr>
-              <a:t>Acknowledgements</a:t>
-            </a:r>
-            <a:endParaRPr lang="en-US" sz="1400" dirty="0"/>
-          </a:p>
-        </p:txBody>
-      </p:sp>
-      <p:sp>
-        <p:nvSpPr>
-          <p:cNvPr id="11" name="Text 8"/>
-          <p:cNvSpPr txBox="1"/>
-          <p:nvPr/>
-        </p:nvSpPr>
-        <p:spPr>
-          <a:xfrm>
-            <a:off x="7818120" y="4919472"/>
-            <a:ext cx="3596335" cy="1280160"/>
-          </a:xfrm>
-          <a:prstGeom prst="rect">
-            <a:avLst/>
-          </a:prstGeom>
-          <a:noFill/>
-          <a:ln/>
-        </p:spPr>
-        <p:txBody>
-          <a:bodyPr wrap="square" lIns="0" tIns="0" rIns="0" bIns="0" rtlCol="0" anchor="t"/>
-          <a:lstStyle/>
-          <a:p>
-            <a:pPr indent="0" marL="0">
-              <a:buNone/>
-            </a:pPr>
-            <a:r>
               <a:rPr lang="en-US" sz="1100" dirty="0">
                 <a:solidFill>
                   <a:schemeClr val="tx1"/>
                 </a:solidFill>
               </a:rPr>
-              <a:t>Complaint narratives published by the CFPB with consumer consent, personal data removed at source. AI coding tools (Claude Code) helped build the service and test scripts and draft documents; all labels, test runs and the recommendation are the team's own.</a:t>
+              <a:t>Complaint narratives published by the CFPB with consumer consent, personal data removed at source. Built with Llama. AI coding tools (Claude Code) helped build the service and test scripts and draft documents; all labels, test runs and the recommendation are the team's own.</a:t>
             </a:r>
             <a:endParaRPr lang="en-US" sz="1100" dirty="0"/>
           </a:p>
@@ -7370,7 +7238,7 @@
                   <a:schemeClr val="tx1"/>
                 </a:solidFill>
               </a:rPr>
-              <a:t>Apache JMeter 5.6.3 plays the bank: new complaints arriving, and staff searching past tickets</a:t>
+              <a:t>Apache JMeter 5.6.3 [2] plays the bank: new complaints arriving, and staff searching past tickets</a:t>
             </a:r>
             <a:endParaRPr lang="en-US" sz="1200" dirty="0"/>
           </a:p>
@@ -7669,7 +7537,7 @@
                   <a:schemeClr val="bg1"/>
                 </a:solidFill>
               </a:rPr>
-              <a:t>AI model server (Ollama)</a:t>
+              <a:t>AI model server (Ollama) [1]</a:t>
             </a:r>
             <a:endParaRPr lang="en-US" sz="1400" dirty="0"/>
           </a:p>
@@ -8621,7 +8489,7 @@
                   <a:schemeClr val="accent1"/>
                 </a:solidFill>
               </a:rPr>
-              <a:t>SOURCED [1]</a:t>
+              <a:t>SOURCED [3]</a:t>
             </a:r>
             <a:endParaRPr lang="en-US" sz="1000" dirty="0"/>
           </a:p>
@@ -8754,7 +8622,7 @@
                   <a:schemeClr val="accent1"/>
                 </a:solidFill>
               </a:rPr>
-              <a:t>ESTIMATED</a:t>
+              <a:t>EST. FROM [4]</a:t>
             </a:r>
             <a:endParaRPr lang="en-US" sz="1000" dirty="0"/>
           </a:p>
@@ -9020,7 +8888,7 @@
                   <a:srgbClr val="9BC1BC"/>
                 </a:solidFill>
               </a:rPr>
-              <a:t>EST. FROM [3][4]</a:t>
+              <a:t>EST. FROM [5], [6]</a:t>
             </a:r>
             <a:endParaRPr lang="en-US" sz="1000" dirty="0"/>
           </a:p>
@@ -10097,7 +9965,7 @@
                   <a:schemeClr val="tx1"/>
                 </a:solidFill>
               </a:rPr>
-              <a:t>We count phone complaints as tickets too, and move out-of-hours ones into office hours. Both make our test harder than reality</a:t>
+              <a:t>We count phone complaints as tickets too, and move out-of-hours ones into office hours. Both make our test harder than reality [7]</a:t>
             </a:r>
             <a:endParaRPr lang="en-US" sz="1200" dirty="0"/>
           </a:p>
@@ -11051,7 +10919,7 @@
                             <a:schemeClr val="tx1"/>
                           </a:solidFill>
                         </a:rPr>
-                        <a:t>Staff wait at the screen; about 1 s keeps their train of thought [7]</a:t>
+                        <a:t>Staff wait at the screen; about 1 s keeps their train of thought [9]</a:t>
                       </a:r>
                       <a:endParaRPr lang="en-US" sz="1200" dirty="0"/>
                     </a:p>
@@ -12195,7 +12063,7 @@
                   <a:schemeClr val="tx1"/>
                 </a:solidFill>
               </a:rPr>
-              <a:t>Apache 2.0</a:t>
+              <a:t>Apache 2.0 [11]</a:t>
             </a:r>
             <a:endParaRPr lang="en-US" sz="1200" dirty="0"/>
           </a:p>
@@ -12231,7 +12099,7 @@
                   <a:schemeClr val="accent5"/>
                 </a:solidFill>
               </a:rPr>
-              <a:t>Fastest. Same maker as the large one, so only size differs</a:t>
+              <a:t>Fastest. Same maker as the large one [10], so only size differs</a:t>
             </a:r>
             <a:endParaRPr lang="en-US" sz="1200" dirty="0"/>
           </a:p>
@@ -12431,7 +12299,7 @@
                   <a:schemeClr val="tx1"/>
                 </a:solidFill>
               </a:rPr>
-              <a:t>Llama 3.2 Community</a:t>
+              <a:t>Llama 3.2 Community [12]</a:t>
             </a:r>
             <a:endParaRPr lang="en-US" sz="1200" dirty="0"/>
           </a:p>
@@ -12667,7 +12535,7 @@
                   <a:schemeClr val="tx1"/>
                 </a:solidFill>
               </a:rPr>
-              <a:t>Apache 2.0</a:t>
+              <a:t>Apache 2.0 [11]</a:t>
             </a:r>
             <a:endParaRPr lang="en-US" sz="1200" dirty="0"/>
           </a:p>
@@ -13457,7 +13325,7 @@
                   <a:schemeClr val="accent5"/>
                 </a:solidFill>
               </a:rPr>
-              <a:t>All three are compressed the same way (Q4_K_M), so size is the only difference. A fourth, qwen2.5:3b, was planned but not tested: its licence bans commercial use (fails C2).</a:t>
+              <a:t>All three are compressed the same way (Q4_K_M), so size is the only difference.</a:t>
             </a:r>
             <a:endParaRPr lang="en-US" sz="1200" dirty="0"/>
           </a:p>

</xml_diff>

<commit_message>
Update slides with verified adaptive stress results
</commit_message>
<xml_diff>
--- a/slides/Group03.pptx
+++ b/slides/Group03.pptx
@@ -1717,7 +1717,7 @@
           <a:p>
             <a:r>
               <a:rPr lang="en-US" dirty="0"/>
-              <a:t>Predictions: planning/prediction-record.md at tag prediction-freeze (2026-10-06 15:36 SGT). Outcomes: slides 9 and 10. Latency correlation r computed from service logs of the 27 load runs. Single-request latency from the sequential accuracy runs.</a:t>
+              <a:t>Predictions: planning/prediction-record.md at tag prediction-freeze (2026-10-06 15:36 SGT). Outcomes: slides 9 and 10. Latency correlation r computed from service logs of the 27 load runs. Single-request latency from the sequential accuracy runs. Final stress evidence revises the old capacity estimate: 20/min sustained in one attempt, 22/min mixed across two, 24/min overloaded in both reset-and-warm attempts. No accuracy or standard peak-load requirement changed. 20/1.73 = 11.56 times the modelled peak. This is test-machine headroom, not a promise for untested bank hardware.</a:t>
             </a:r>
             <a:endParaRPr lang="en-US" dirty="0"/>
           </a:p>
@@ -2333,7 +2333,7 @@
           <a:p>
             <a:r>
               <a:rPr lang="en-US" dirty="0"/>
-              <a:t>Sources: evidence/smoke-prototype/env/service_machine.txt (SUT), results/load/*/..._jmeter.log (LG: os.name, java.version, JMeter version), service logs for search latency, *_stats.csv for docker stats.</a:t>
+              <a:t>Sources: evidence/smoke-prototype/env/service_machine.txt (SUT), results/load/*/..._jmeter.log (LG: os.name, java.version, JMeter version), service logs for search latency, *_stats.csv for docker stats. Adaptive stress evidence: results/load/qwen2.5-7b/adaptive-stress/adaptive-stress-summary.json and matching JTL files. At 20/min one 10-minute attempt sustained the offered load. At 22/min one attempt overloaded and one sustained. At 24/min two independent attempts met the predeclared overload rule. These short tests do not establish a production SLA or a reliable 22/min operating rate.</a:t>
             </a:r>
             <a:endParaRPr lang="en-US" dirty="0"/>
           </a:p>
@@ -2421,7 +2421,7 @@
           <a:p>
             <a:r>
               <a:rPr lang="en-US" dirty="0"/>
-              <a:t>Full step-by-step playbook: docs/actual-jmeter-test.md and docs/load-testing.md. Runners: scripts/run_official_jmeter_suite.py, scripts/run_7b_stress_suite.py, scripts/run_accuracy_suite.py. Reconciliation: scripts/reconcile.py. Summary: scripts/summarise_jtl.py.</a:t>
+              <a:t>Full step-by-step playbook: docs/actual-jmeter-test.md and docs/load-testing.md. Runners: scripts/run_official_jmeter_suite.py, scripts/run_7b_stress_suite.py, scripts/run_accuracy_suite.py. Reconciliation: scripts/reconcile.py. Summary: scripts/summarise_jtl.py. Final stress procedure: docs/adaptive-stress-test.md and scripts/run_adaptive_stress.py. Final sequence 20, 22, 24 POST/min plus 7 searches/min. Each stage 10 active minutes, 10 drain minutes, reset and invented warm-up. Overload rules: errors &gt;1%; end backlog &gt;= max(5, ceil(15% of POST count)); growing backlog plus last-half completion throughput &lt;90% offered; or growing backlog plus late-half p50 &gt;=1.5 times early-half p50 with &gt;=2 seconds absolute increase. Repeat an overload signal. Earlier adaptive_14rpm_s7_run1 had connection/socket timeouts and is excluded from the final capacity conclusion.</a:t>
             </a:r>
             <a:endParaRPr lang="en-US" dirty="0"/>
           </a:p>
@@ -2509,7 +2509,7 @@
           <a:p>
             <a:r>
               <a:rPr lang="en-US" dirty="0"/>
-              <a:t>Source: python scripts/summarise_jtl.py results/load (POST /tickets) and --label "GET /search". Values are mean (min–max) over 3 runs; no warm-up skip. Error rate 0.0% in all 27 runs: 0 of 594 POSTs, 0 of 1,206 searches. Ollama queue wait from service logs: ollama_total_ms − prompt_eval_ms − eval_ms. CPU from *_stats.csv.</a:t>
+              <a:t>Source: python scripts/summarise_jtl.py results/load (POST /tickets) and --label "GET /search". Values are mean (min–max) over 3 runs; no warm-up skip. Error rate 0.0% in all 27 runs: 0 of 594 POSTs, 0 of 1,206 searches. Ollama queue wait from service logs: ollama_total_ms − prompt_eval_ms − eval_ms. CPU from *_stats.csv. Final stress source: results/load/qwen2.5-7b/adaptive-stress/adaptive-stress-summary.json. Independently recomputed from the five final JTLs and reconciled with per-run service logs. All five final attempts have zero POST failures. POST p50/p95/p99 in seconds: 20 run1 9.051/21.831/25.274; 22 run1 16.207/31.897/38.468; 22 run2 25.334/43.972/46.545; 24 run1 26.617/53.816/64.126; 24 run2 34.011/71.663/75.021. Last-half successful completions/min: 20.8, 21.6, 22.4, 23.0, 22.8. Backlog midpoint/end: 1/4, 8/12, 10/7, 15/24, 13/27. At 22/min outcomes were mixed; do not promise reliable sustained capacity there. At 24/min backlog and late-half latency grew in both independent attempts. Ollama CPU p95 1008.62%/1013.85%, triage p95 0.81%/0.87%. Stats summaries include monitoring/drain, so CPU p95 is supporting evidence, not proof of continuous saturation. The earlier 14/min first attempt had timeouts and is not included in this final conclusion.</a:t>
             </a:r>
             <a:endParaRPr lang="en-US" dirty="0"/>
           </a:p>
@@ -5456,7 +5456,7 @@
                             <a:schemeClr val="tx1"/>
                           </a:solidFill>
                         </a:rPr>
-                        <a:t>Kept up at 9.6 /min: 95% within 17.3 s, none failed</a:t>
+                        <a:t>20/min sustained; 22/min mixed; overload at 24/min in both attempts</a:t>
                       </a:r>
                       <a:endParaRPr lang="en-US" sz="1100" dirty="0"/>
                     </a:p>
@@ -6463,7 +6463,7 @@
                   <a:schemeClr val="bg1"/>
                 </a:solidFill>
               </a:rPr>
-              <a:t>Its licence (Apache 2.0 [11]) allows commercial use; runs on one standard server</a:t>
+              <a:t>Apache 2.0 [11] permits commercial use. 20/min sustained in the stress check, over 11× our peak load</a:t>
             </a:r>
             <a:endParaRPr lang="en-US" sz="1200" dirty="0"/>
           </a:p>
@@ -14937,7 +14937,7 @@
                   <a:schemeClr val="tx1"/>
                 </a:solidFill>
               </a:rPr>
-              <a:t>Capacity ≈ 60 s ÷ time per ticket: 3.1 s here, so about 19 tickets a minute for the large model</a:t>
+              <a:t>Stress check: 20 tickets/min sustained, 22/min mixed, 24/min overloaded twice, with 7 searches/min</a:t>
             </a:r>
             <a:endParaRPr lang="en-US" sz="1200" dirty="0"/>
           </a:p>
@@ -15070,7 +15070,7 @@
                   <a:schemeClr val="tx1"/>
                 </a:solidFill>
               </a:rPr>
-              <a:t>Each 10-min run has only 14–35 tickets, so the slowest-1% figure (p99) is just the slowest ticket</a:t>
+              <a:t>Standard load runs have only 14–35 tickets each, so p99 is just the slowest ticket</a:t>
             </a:r>
             <a:endParaRPr lang="en-US" sz="1200" dirty="0"/>
           </a:p>
@@ -16606,7 +16606,7 @@
                   <a:schemeClr val="tx1"/>
                 </a:solidFill>
               </a:rPr>
-              <a:t>Traffic rises steadily from 3.5 to 12 tickets/min over 30 min, plus 7 searches/min</a:t>
+              <a:t>After the first ramp, test higher fixed rates with 7 searches/min and repeat each overload signal</a:t>
             </a:r>
             <a:endParaRPr lang="en-US" sz="1200" dirty="0"/>
           </a:p>
@@ -16624,7 +16624,7 @@
                   <a:schemeClr val="tx1"/>
                 </a:solidFill>
               </a:rPr>
-              <a:t>Then 15 min at a steady 7.2 and 9.6 tickets/min to confirm</a:t>
+              <a:t>Each new attempt: 10 min of traffic, 10 min to drain, with the same reset and warm-up</a:t>
             </a:r>
             <a:endParaRPr lang="en-US" sz="1200" dirty="0"/>
           </a:p>
@@ -16642,7 +16642,7 @@
                   <a:schemeClr val="tx1"/>
                 </a:solidFill>
               </a:rPr>
-              <a:t>The limit is where tickets arrive faster than they are sorted and delays keep growing</a:t>
+              <a:t>Overload: failures &gt;1%, ≥15% still in flight, or a growing queue with slower completions or rising latency</a:t>
             </a:r>
             <a:endParaRPr lang="en-US" sz="1200" dirty="0"/>
           </a:p>
@@ -16660,7 +16660,7 @@
                   <a:schemeClr val="tx1"/>
                 </a:solidFill>
               </a:rPr>
-              <a:t>Each ticket's time is split into waiting in line vs being processed</a:t>
+              <a:t>Check queue size at 5 and 10 min, early vs late latency, throughput, failures and processor use</a:t>
             </a:r>
             <a:endParaRPr lang="en-US" sz="1200" dirty="0"/>
           </a:p>
@@ -21807,7 +21807,7 @@
                   <a:schemeClr val="bg1"/>
                 </a:solidFill>
               </a:rPr>
-              <a:t>Rising 3.5 → 12 /min</a:t>
+              <a:t>20 /min: sustained</a:t>
             </a:r>
             <a:endParaRPr lang="en-US" sz="1200" dirty="0"/>
           </a:p>
@@ -21843,7 +21843,7 @@
                   <a:srgbClr val="CADDDA"/>
                 </a:solidFill>
               </a:rPr>
-              <a:t>232 tickets · 95% within 10.2 s · 0 failed</a:t>
+              <a:t>200 tickets · p95 21.8 s · 0 failed</a:t>
             </a:r>
             <a:endParaRPr lang="en-US" sz="1100" dirty="0"/>
           </a:p>
@@ -21879,7 +21879,7 @@
                   <a:schemeClr val="bg1"/>
                 </a:solidFill>
               </a:rPr>
-              <a:t>Steady 7.2 /min</a:t>
+              <a:t>22 /min: mixed (2 attempts)</a:t>
             </a:r>
             <a:endParaRPr lang="en-US" sz="1200" dirty="0"/>
           </a:p>
@@ -21915,7 +21915,7 @@
                   <a:srgbClr val="CADDDA"/>
                 </a:solidFill>
               </a:rPr>
-              <a:t>108 tickets · 95% within 8.7 s · 0 failed</a:t>
+              <a:t>p95 31.9 / 44.0 s · 0 failed</a:t>
             </a:r>
             <a:endParaRPr lang="en-US" sz="1100" dirty="0"/>
           </a:p>
@@ -21951,7 +21951,7 @@
                   <a:schemeClr val="bg1"/>
                 </a:solidFill>
               </a:rPr>
-              <a:t>Steady 9.6 /min</a:t>
+              <a:t>24 /min: overloaded twice</a:t>
             </a:r>
             <a:endParaRPr lang="en-US" sz="1200" dirty="0"/>
           </a:p>
@@ -21987,7 +21987,7 @@
                   <a:srgbClr val="CADDDA"/>
                 </a:solidFill>
               </a:rPr>
-              <a:t>144 tickets · 95% within 17.3 s · 0 failed</a:t>
+              <a:t>p95 53.8 / 71.7 s · 0 failed</a:t>
             </a:r>
             <a:endParaRPr lang="en-US" sz="1100" dirty="0"/>
           </a:p>
@@ -22026,7 +22026,7 @@
                 <a:ea typeface="Cambria" pitchFamily="34" charset="-122"/>
                 <a:cs typeface="Cambria" pitchFamily="34" charset="-120"/>
               </a:rPr>
-              <a:t>No limit found up to 12 /min</a:t>
+              <a:t>Overload confirmed at 24 /min</a:t>
             </a:r>
             <a:endParaRPr lang="en-US" sz="1400" dirty="0"/>
           </a:p>
@@ -22062,7 +22062,7 @@
                   <a:schemeClr val="bg1"/>
                 </a:solidFill>
               </a:rPr>
-              <a:t>It kept up at 9.6 /min, 5.5× the busiest hour, without delays growing. We estimate it tops out near 19 /min (60 s ÷ 3.1 s per ticket); not yet confirmed.</a:t>
+              <a:t>At 24/min, in-flight tickets grew from 15 to 24 and 13 to 27. Late-half typical latency rose 1.80× and 3.37×. All requests eventually finished.</a:t>
             </a:r>
             <a:endParaRPr lang="en-US" sz="1100" dirty="0"/>
           </a:p>
@@ -22137,7 +22137,7 @@
                   <a:schemeClr val="bg1"/>
                 </a:solidFill>
               </a:rPr>
-              <a:t>Tickets wait under 0.1 s in our service, but up to 14.6 s (95%) in the model's own queue at 9.6 /min. The model keeps ~10 cores busy; our service under 7% of one.</a:t>
+              <a:t>At 24/min, late-half completions were 23.0 and 22.8/min, below arrivals. Model CPU p95 was about 10 cores; service CPU p95 stayed below 1% of one core.</a:t>
             </a:r>
             <a:endParaRPr lang="en-US" sz="1100" dirty="0"/>
           </a:p>

</xml_diff>

<commit_message>
State stress limit as 20-24/min; name stress rates and earlier runs
Slides 7, 9 and 11 give the 7B limit as between 20 and 24 tickets/min.
Slide 8's stress playbook names the 3.5-12/min ramp and the 12-24/min
steps; slide 9 notes the earlier runs and the 14/min attempt with Wi-Fi
timeouts that was repeated.
</commit_message>
<xml_diff>
--- a/slides/Group03.pptx
+++ b/slides/Group03.pptx
@@ -118,31 +118,31 @@
   <p:extLst>
     <p:ext uri="{521415D9-36F7-43E2-AB2F-B90AF26B5E84}">
       <p14:sectionLst xmlns:p14="http://schemas.microsoft.com/office/powerpoint/2010/main">
-        <p14:section name="Introduction" id="{3c780a86-3036-583a-49d9-5fb0cf74fc23}">
+        <p14:section name="Introduction" id="{0151b342-cb32-3442-7b14-5412941a234b}">
           <p14:sldIdLst>
             <p14:sldId id="256"/>
           </p14:sldIdLst>
         </p14:section>
-        <p14:section name="System and workload" id="{bd3493fb-ffd0-c25b-27e7-a53bbb10ec98}">
+        <p14:section name="System and workload" id="{4ae40a49-4181-3c66-22a4-280f0a8e2fda}">
           <p14:sldIdLst>
             <p14:sldId id="257"/>
             <p14:sldId id="258"/>
           </p14:sldIdLst>
         </p14:section>
-        <p14:section name="Requirements and candidates" id="{a7649814-2570-e00c-bcfa-fa22d25b7fde}">
+        <p14:section name="Requirements and candidates" id="{dd29227e-60e4-cc18-b53d-d68f331dde03}">
           <p14:sldIdLst>
             <p14:sldId id="259"/>
             <p14:sldId id="260"/>
           </p14:sldIdLst>
         </p14:section>
-        <p14:section name="Golden set and testing" id="{6acf025e-6ff1-957c-36d7-a05b6429daa6}">
+        <p14:section name="Golden set and testing" id="{c0f7bc5a-b04d-e8dd-f9f5-e4f207033fa4}">
           <p14:sldIdLst>
             <p14:sldId id="261"/>
             <p14:sldId id="262"/>
             <p14:sldId id="263"/>
           </p14:sldIdLst>
         </p14:section>
-        <p14:section name="Results and recommendation" id="{6a100870-ea1f-5006-e6a0-6081ac680af7}">
+        <p14:section name="Results and recommendation" id="{de6d2dbc-6d1e-b33f-e6a1-e5b524499770}">
           <p14:sldIdLst>
             <p14:sldId id="264"/>
             <p14:sldId id="265"/>
@@ -1717,7 +1717,7 @@
           <a:p>
             <a:r>
               <a:rPr lang="en-US" dirty="0"/>
-              <a:t>Predictions: planning/prediction-record.md at tag prediction-freeze (2026-10-06 15:36 SGT). Outcomes: slides 9 and 10. Latency correlation r computed from service logs of the 27 load runs. Single-request latency from the sequential accuracy runs. Final stress evidence revises the old capacity estimate: 20/min sustained in one attempt, 22/min mixed across two, 24/min overloaded in both reset-and-warm attempts. No accuracy or standard peak-load requirement changed. 20/1.73 = 11.56 times the modelled peak. This is test-machine headroom, not a promise for untested bank hardware.</a:t>
+              <a:t>Predictions: planning/prediction-record.md at tag prediction-freeze (2026-10-06 15:36 SGT). Outcomes: slides 9 and 10. Latency correlation r computed from service logs of the 27 load runs. Single-request latency from the sequential accuracy runs.Final stress evidence revises the old capacity estimate: 20/min sustained in one attempt, 22/min mixed across two, 24/min overloaded in both reset-and-warm attempts. No accuracy or standard peak-load requirement changed. 20/1.73 = 11.56 times the modelled peak. This is test-machine headroom, not a promise for untested bank hardware.</a:t>
             </a:r>
             <a:endParaRPr lang="en-US" dirty="0"/>
           </a:p>
@@ -2333,7 +2333,7 @@
           <a:p>
             <a:r>
               <a:rPr lang="en-US" dirty="0"/>
-              <a:t>Sources: evidence/smoke-prototype/env/service_machine.txt (SUT), results/load/*/..._jmeter.log (LG: os.name, java.version, JMeter version), service logs for search latency, *_stats.csv for docker stats. Adaptive stress evidence: results/load/qwen2.5-7b/adaptive-stress/adaptive-stress-summary.json and matching JTL files. At 20/min one 10-minute attempt sustained the offered load. At 22/min one attempt overloaded and one sustained. At 24/min two independent attempts met the predeclared overload rule. These short tests do not establish a production SLA or a reliable 22/min operating rate.</a:t>
+              <a:t>Sources: evidence/smoke-prototype/env/service_machine.txt (SUT), results/load/*/..._jmeter.log (LG: os.name, java.version, JMeter version), service logs for search latency, *_stats.csv for docker stats.Adaptive stress evidence: results/load/qwen2.5-7b/adaptive-stress/adaptive-stress-summary.json and matching JTL files. At 20/min one 10-minute attempt sustained the offered load. At 22/min one attempt overloaded and one sustained. At 24/min two independent attempts met the predeclared overload rule. These short tests do not establish a production SLA or a reliable 22/min operating rate.</a:t>
             </a:r>
             <a:endParaRPr lang="en-US" dirty="0"/>
           </a:p>
@@ -2421,7 +2421,7 @@
           <a:p>
             <a:r>
               <a:rPr lang="en-US" dirty="0"/>
-              <a:t>Full step-by-step playbook: docs/actual-jmeter-test.md and docs/load-testing.md. Runners: scripts/run_official_jmeter_suite.py, scripts/run_7b_stress_suite.py, scripts/run_accuracy_suite.py. Reconciliation: scripts/reconcile.py. Summary: scripts/summarise_jtl.py. Final stress procedure: docs/adaptive-stress-test.md and scripts/run_adaptive_stress.py. Final sequence 20, 22, 24 POST/min plus 7 searches/min. Each stage 10 active minutes, 10 drain minutes, reset and invented warm-up. Overload rules: errors &gt;1%; end backlog &gt;= max(5, ceil(15% of POST count)); growing backlog plus last-half completion throughput &lt;90% offered; or growing backlog plus late-half p50 &gt;=1.5 times early-half p50 with &gt;=2 seconds absolute increase. Repeat an overload signal. Earlier adaptive_14rpm_s7_run1 had connection/socket timeouts and is excluded from the final capacity conclusion.</a:t>
+              <a:t>Full step-by-step playbook: docs/actual-jmeter-test.md and docs/load-testing.md. Runners: scripts/run_official_jmeter_suite.py, scripts/run_7b_stress_suite.py, scripts/run_accuracy_suite.py. Reconciliation: scripts/reconcile.py. Summary: scripts/summarise_jtl.py.Final stress procedure: docs/adaptive-stress-test.md and scripts/run_adaptive_stress.py. Final sequence 20, 22, 24 POST/min plus 7 searches/min. Each stage 10 active minutes, 10 drain minutes, reset and invented warm-up. Overload rules: errors &gt;1%; end backlog &gt;= max(5, ceil(15% of POST count)); growing backlog plus last-half completion throughput &lt;90% offered; or growing backlog plus late-half p50 &gt;=1.5 times early-half p50 with &gt;=2 seconds absolute increase. Repeat an overload signal. Earlier adaptive_14rpm_s7_run1 had connection/socket timeouts and is excluded from the final capacity conclusion.</a:t>
             </a:r>
             <a:endParaRPr lang="en-US" dirty="0"/>
           </a:p>
@@ -2509,7 +2509,7 @@
           <a:p>
             <a:r>
               <a:rPr lang="en-US" dirty="0"/>
-              <a:t>Source: python scripts/summarise_jtl.py results/load (POST /tickets) and --label "GET /search". Values are mean (min–max) over 3 runs; no warm-up skip. Error rate 0.0% in all 27 runs: 0 of 594 POSTs, 0 of 1,206 searches. Ollama queue wait from service logs: ollama_total_ms − prompt_eval_ms − eval_ms. CPU from *_stats.csv. Final stress source: results/load/qwen2.5-7b/adaptive-stress/adaptive-stress-summary.json. Independently recomputed from the five final JTLs and reconciled with per-run service logs. All five final attempts have zero POST failures. POST p50/p95/p99 in seconds: 20 run1 9.051/21.831/25.274; 22 run1 16.207/31.897/38.468; 22 run2 25.334/43.972/46.545; 24 run1 26.617/53.816/64.126; 24 run2 34.011/71.663/75.021. Last-half successful completions/min: 20.8, 21.6, 22.4, 23.0, 22.8. Backlog midpoint/end: 1/4, 8/12, 10/7, 15/24, 13/27. At 22/min outcomes were mixed; do not promise reliable sustained capacity there. At 24/min backlog and late-half latency grew in both independent attempts. Ollama CPU p95 1008.62%/1013.85%, triage p95 0.81%/0.87%. Stats summaries include monitoring/drain, so CPU p95 is supporting evidence, not proof of continuous saturation. The earlier 14/min first attempt had timeouts and is not included in this final conclusion.</a:t>
+              <a:t>Source: python scripts/summarise_jtl.py results/load (POST /tickets) and --label "GET /search". Values are mean (min–max) over 3 runs; no warm-up skip. Error rate 0.0% in all 27 runs: 0 of 594 POSTs, 0 of 1,206 searches. Ollama queue wait from service logs: ollama_total_ms − prompt_eval_ms − eval_ms. CPU from *_stats.csv.Final stress source: results/load/qwen2.5-7b/adaptive-stress/adaptive-stress-summary.json. Independently recomputed from the five final JTLs and reconciled with per-run service logs. All five final attempts have zero POST failures. POST p50/p95/p99 in seconds: 20 run1 9.051/21.831/25.274; 22 run1 16.207/31.897/38.468; 22 run2 25.334/43.972/46.545; 24 run1 26.617/53.816/64.126; 24 run2 34.011/71.663/75.021. Last-half successful completions/min: 20.8, 21.6, 22.4, 23.0, 22.8. Backlog midpoint/end: 1/4, 8/12, 10/7, 15/24, 13/27. At 22/min outcomes were mixed; do not promise reliable sustained capacity there. At 24/min backlog and late-half latency grew in both independent attempts. Ollama CPU p95 1008.62%/1013.85%, triage p95 0.81%/0.87%. Stats summaries include monitoring/drain, so CPU p95 is supporting evidence, not proof of continuous saturation. The earlier 14/min first attempt had timeouts and is not included in this final conclusion.</a:t>
             </a:r>
             <a:endParaRPr lang="en-US" dirty="0"/>
           </a:p>
@@ -5456,7 +5456,7 @@
                             <a:schemeClr val="tx1"/>
                           </a:solidFill>
                         </a:rPr>
-                        <a:t>20/min sustained; 22/min mixed; overload at 24/min in both attempts</a:t>
+                        <a:t>Limit between 20 and 24 /min: 20 kept up, 24 overloaded twice</a:t>
                       </a:r>
                       <a:endParaRPr lang="en-US" sz="1100" dirty="0"/>
                     </a:p>
@@ -14937,7 +14937,7 @@
                   <a:schemeClr val="tx1"/>
                 </a:solidFill>
               </a:rPr>
-              <a:t>Stress check: 20 tickets/min sustained, 22/min mixed, 24/min overloaded twice, with 7 searches/min</a:t>
+              <a:t>Stress check: the limit lies between 20 and 24 tickets/min (with 7 searches/min)</a:t>
             </a:r>
             <a:endParaRPr lang="en-US" sz="1200" dirty="0"/>
           </a:p>
@@ -16606,7 +16606,7 @@
                   <a:schemeClr val="tx1"/>
                 </a:solidFill>
               </a:rPr>
-              <a:t>After the first ramp, test higher fixed rates with 7 searches/min and repeat each overload signal</a:t>
+              <a:t>After a 3.5→12/min ramp, steady rates from 12 to 24 tickets/min in steps of 2, plus 7 searches/min; repeat any overload</a:t>
             </a:r>
             <a:endParaRPr lang="en-US" sz="1200" dirty="0"/>
           </a:p>
@@ -22026,7 +22026,7 @@
                 <a:ea typeface="Cambria" pitchFamily="34" charset="-122"/>
                 <a:cs typeface="Cambria" pitchFamily="34" charset="-120"/>
               </a:rPr>
-              <a:t>Overload confirmed at 24 /min</a:t>
+              <a:t>Limit: 20–24 /min</a:t>
             </a:r>
             <a:endParaRPr lang="en-US" sz="1400" dirty="0"/>
           </a:p>
@@ -22062,7 +22062,7 @@
                   <a:schemeClr val="bg1"/>
                 </a:solidFill>
               </a:rPr>
-              <a:t>At 24/min, in-flight tickets grew from 15 to 24 and 13 to 27. Late-half typical latency rose 1.80× and 3.37×. All requests eventually finished.</a:t>
+              <a:t>Earlier runs from 3.5 to 18 /min all kept up; one 14 /min attempt had 3 tickets fail on Wi-Fi timeouts and was repeated cleanly. At 24 /min the queue grew in both attempts (15→24, 13→27).</a:t>
             </a:r>
             <a:endParaRPr lang="en-US" sz="1100" dirty="0"/>
           </a:p>
@@ -22076,7 +22076,7 @@
         </p:nvSpPr>
         <p:spPr>
           <a:xfrm>
-            <a:off x="8961120" y="4709160"/>
+            <a:off x="8961120" y="4846320"/>
             <a:ext cx="2499055" cy="320040"/>
           </a:xfrm>
           <a:prstGeom prst="rect">
@@ -22115,8 +22115,8 @@
         </p:nvSpPr>
         <p:spPr>
           <a:xfrm>
-            <a:off x="8961120" y="5047488"/>
-            <a:ext cx="2499055" cy="1143000"/>
+            <a:off x="8961120" y="5184648"/>
+            <a:ext cx="2499055" cy="1005840"/>
           </a:xfrm>
           <a:prstGeom prst="rect">
             <a:avLst/>

</xml_diff>

<commit_message>
Drop FCA glossary reference; point Llama licence at Meta's GitHub
The FCA glossary page no longer loads, so its reference and slide 3
marker are removed and references 8-12 renumbered to 7-11. The Llama 3.2
licence now links to meta-llama/llama-models on GitHub, as llama.com's
page returns 404.
</commit_message>
<xml_diff>
--- a/slides/Group03.pptx
+++ b/slides/Group03.pptx
@@ -118,31 +118,31 @@
   <p:extLst>
     <p:ext uri="{521415D9-36F7-43E2-AB2F-B90AF26B5E84}">
       <p14:sectionLst xmlns:p14="http://schemas.microsoft.com/office/powerpoint/2010/main">
-        <p14:section name="Introduction" id="{0151b342-cb32-3442-7b14-5412941a234b}">
+        <p14:section name="Introduction" id="{fd274df9-f16e-1f70-9a41-75b9f600c22e}">
           <p14:sldIdLst>
             <p14:sldId id="256"/>
           </p14:sldIdLst>
         </p14:section>
-        <p14:section name="System and workload" id="{4ae40a49-4181-3c66-22a4-280f0a8e2fda}">
+        <p14:section name="System and workload" id="{8c55f67c-8eb9-1a3a-6824-7d5d3da3409b}">
           <p14:sldIdLst>
             <p14:sldId id="257"/>
             <p14:sldId id="258"/>
           </p14:sldIdLst>
         </p14:section>
-        <p14:section name="Requirements and candidates" id="{dd29227e-60e4-cc18-b53d-d68f331dde03}">
+        <p14:section name="Requirements and candidates" id="{19618977-8a94-ee35-12c1-80314c080fc4}">
           <p14:sldIdLst>
             <p14:sldId id="259"/>
             <p14:sldId id="260"/>
           </p14:sldIdLst>
         </p14:section>
-        <p14:section name="Golden set and testing" id="{c0f7bc5a-b04d-e8dd-f9f5-e4f207033fa4}">
+        <p14:section name="Golden set and testing" id="{d4882448-08d0-7fe7-e8fd-6d7c9346f86b}">
           <p14:sldIdLst>
             <p14:sldId id="261"/>
             <p14:sldId id="262"/>
             <p14:sldId id="263"/>
           </p14:sldIdLst>
         </p14:section>
-        <p14:section name="Results and recommendation" id="{de6d2dbc-6d1e-b33f-e6a1-e5b524499770}">
+        <p14:section name="Results and recommendation" id="{2400c6df-7696-a1d1-b10b-de19b1b008df}">
           <p14:sldIdLst>
             <p14:sldId id="264"/>
             <p14:sldId id="265"/>
@@ -185,7 +185,7 @@
                 </a:solidFill>
                 <a:latin typeface="+mn-lt"/>
               </a:rPr>
-              <a:t>Ticket length in characters (our 1,000) [8]</a:t>
+              <a:t>Ticket length in characters (our 1,000) [7]</a:t>
             </a:r>
           </a:p>
         </c:rich>
@@ -6463,7 +6463,7 @@
                   <a:schemeClr val="bg1"/>
                 </a:solidFill>
               </a:rPr>
-              <a:t>Apache 2.0 [11] permits commercial use. 20/min sustained in the stress check, over 11× our peak load</a:t>
+              <a:t>Apache 2.0 [10] permits commercial use. 20/min sustained in the stress check, over 11× our peak load</a:t>
             </a:r>
             <a:endParaRPr lang="en-US" sz="1200" dirty="0"/>
           </a:p>
@@ -6846,7 +6846,7 @@
                   <a:schemeClr val="tx1"/>
                 </a:solidFill>
               </a:rPr>
-              <a:t>[7] Financial Conduct Authority, "Complaint," FCA Handbook Glossary. [Online]. Available: https://www.handbook.fca.org.uk/handbook/glossary/G197.html. Accessed: Oct. 9, 2026.</a:t>
+              <a:t>[7] Consumer Financial Protection Bureau, "Consumer Complaint Database." [Online]. Available: https://www.consumerfinance.gov/data-research/consumer-complaints/. Course extract (rows 3000–3999) provided by Singapore Institute of Technology for ICT3113 via xSiTe.</a:t>
             </a:r>
             <a:endParaRPr lang="en-US" sz="1100" dirty="0"/>
           </a:p>
@@ -6863,7 +6863,7 @@
                   <a:schemeClr val="tx1"/>
                 </a:solidFill>
               </a:rPr>
-              <a:t>[8] Consumer Financial Protection Bureau, "Consumer Complaint Database." [Online]. Available: https://www.consumerfinance.gov/data-research/consumer-complaints/. Course extract (rows 3000–3999) provided by Singapore Institute of Technology for ICT3113 via xSiTe.</a:t>
+              <a:t>[8] J. Nielsen, "Response times: The 3 important limits," Nielsen Norman Group, Jan. 1, 1993. [Online]. Available: https://www.nngroup.com/articles/response-times-3-important-limits/. Accessed: Oct. 9, 2026.</a:t>
             </a:r>
             <a:endParaRPr lang="en-US" sz="1100" dirty="0"/>
           </a:p>
@@ -6880,7 +6880,7 @@
                   <a:schemeClr val="tx1"/>
                 </a:solidFill>
               </a:rPr>
-              <a:t>[9] J. Nielsen, "Response times: The 3 important limits," Nielsen Norman Group, Jan. 1, 1993. [Online]. Available: https://www.nngroup.com/articles/response-times-3-important-limits/. Accessed: Oct. 9, 2026.</a:t>
+              <a:t>[9] A. Yang et al., "Qwen2.5 technical report," 2024, arXiv:2412.15115.</a:t>
             </a:r>
             <a:endParaRPr lang="en-US" sz="1100" dirty="0"/>
           </a:p>
@@ -6897,7 +6897,7 @@
                   <a:schemeClr val="tx1"/>
                 </a:solidFill>
               </a:rPr>
-              <a:t>[10] A. Yang et al., "Qwen2.5 technical report," 2024, arXiv:2412.15115.</a:t>
+              <a:t>[10] The Apache Software Foundation, "Apache License, Version 2.0," Jan. 2004. [Online]. Available: https://www.apache.org/licenses/LICENSE-2.0. Accessed: Oct. 9, 2026.</a:t>
             </a:r>
             <a:endParaRPr lang="en-US" sz="1100" dirty="0"/>
           </a:p>
@@ -6914,24 +6914,7 @@
                   <a:schemeClr val="tx1"/>
                 </a:solidFill>
               </a:rPr>
-              <a:t>[11] The Apache Software Foundation, "Apache License, Version 2.0," Jan. 2004. [Online]. Available: https://www.apache.org/licenses/LICENSE-2.0. Accessed: Oct. 9, 2026.</a:t>
-            </a:r>
-            <a:endParaRPr lang="en-US" sz="1100" dirty="0"/>
-          </a:p>
-          <a:p>
-            <a:pPr indent="0" marL="0">
-              <a:spcAft>
-                <a:spcPts val="600"/>
-              </a:spcAft>
-              <a:buNone/>
-            </a:pPr>
-            <a:r>
-              <a:rPr lang="en-US" sz="1100" dirty="0">
-                <a:solidFill>
-                  <a:schemeClr val="tx1"/>
-                </a:solidFill>
-              </a:rPr>
-              <a:t>[12] Meta Platforms, "Llama 3.2 Community License Agreement," Sep. 25, 2024. [Online]. Available: https://www.llama.com/llama3_2/license/. Accessed: Oct. 9, 2026.</a:t>
+              <a:t>[11] Meta Platforms, "Llama 3.2 Community License Agreement," Sep. 25, 2024. [Online]. Available: https://github.com/meta-llama/llama-models/blob/main/models/llama3_2/LICENSE. Accessed: Oct. 9, 2026.</a:t>
             </a:r>
             <a:endParaRPr lang="en-US" sz="1100" dirty="0"/>
           </a:p>
@@ -9965,7 +9948,7 @@
                   <a:schemeClr val="tx1"/>
                 </a:solidFill>
               </a:rPr>
-              <a:t>We count phone complaints as tickets too, and move out-of-hours ones into office hours. Both make our test harder than reality [7]</a:t>
+              <a:t>We count phone complaints as tickets too, and move out-of-hours ones into office hours. Both make our test harder than reality</a:t>
             </a:r>
             <a:endParaRPr lang="en-US" sz="1200" dirty="0"/>
           </a:p>
@@ -10919,7 +10902,7 @@
                             <a:schemeClr val="tx1"/>
                           </a:solidFill>
                         </a:rPr>
-                        <a:t>Staff wait at the screen; about 1 s keeps their train of thought [9]</a:t>
+                        <a:t>Staff wait at the screen; about 1 s keeps their train of thought [8]</a:t>
                       </a:r>
                       <a:endParaRPr lang="en-US" sz="1200" dirty="0"/>
                     </a:p>
@@ -12063,7 +12046,7 @@
                   <a:schemeClr val="tx1"/>
                 </a:solidFill>
               </a:rPr>
-              <a:t>Apache 2.0 [11]</a:t>
+              <a:t>Apache 2.0 [10]</a:t>
             </a:r>
             <a:endParaRPr lang="en-US" sz="1200" dirty="0"/>
           </a:p>
@@ -12099,7 +12082,7 @@
                   <a:schemeClr val="accent5"/>
                 </a:solidFill>
               </a:rPr>
-              <a:t>Fastest. Same maker as the large one [10], so only size differs</a:t>
+              <a:t>Fastest. Same maker as the large one [9], so only size differs</a:t>
             </a:r>
             <a:endParaRPr lang="en-US" sz="1200" dirty="0"/>
           </a:p>
@@ -12299,7 +12282,7 @@
                   <a:schemeClr val="tx1"/>
                 </a:solidFill>
               </a:rPr>
-              <a:t>Llama 3.2 Community [12]</a:t>
+              <a:t>Llama 3.2 Community [11]</a:t>
             </a:r>
             <a:endParaRPr lang="en-US" sz="1200" dirty="0"/>
           </a:p>
@@ -12535,7 +12518,7 @@
                   <a:schemeClr val="tx1"/>
                 </a:solidFill>
               </a:rPr>
-              <a:t>Apache 2.0 [11]</a:t>
+              <a:t>Apache 2.0 [10]</a:t>
             </a:r>
             <a:endParaRPr lang="en-US" sz="1200" dirty="0"/>
           </a:p>

</xml_diff>